<commit_message>
Refine narrative arc: support as proving ground, AXS Intelligence as unlock
Initiative map: box around Support row with START HERE label and annotation
explaining why measurable, well-understood domains are the right starting
point for AI adoption. AXS Support Agent still highlighted as the pilot.

2031 vision: AXS Intelligence Platform promoted to full-width highlighted
card with THE UNLOCK label. Remaining vision cards shown below as outcomes
that proven pilots and infrastructure make possible.
</commit_message>
<xml_diff>
--- a/deliverables/SRAM_AI_Adoption_Playbook.pptx
+++ b/deliverables/SRAM_AI_Adoption_Playbook.pptx
@@ -10527,7 +10527,7 @@
               </a:defRPr>
             </a:pPr>
             <a:r>
-              <a:t>Every function at SRAM has AI potential. Ordered by implementation complexity and time to return.</a:t>
+              <a:t>Start where domain knowledge is high and outcomes are measurable. Support is the proving ground for everything that follows.</a:t>
             </a:r>
           </a:p>
         </p:txBody>
@@ -10735,7 +10735,7 @@
         <p:spPr>
           <a:xfrm>
             <a:off x="731520" y="1920240"/>
-            <a:ext cx="50800" cy="960120"/>
+            <a:ext cx="50800" cy="822960"/>
           </a:xfrm>
           <a:prstGeom prst="rect">
             <a:avLst/>
@@ -10777,8 +10777,8 @@
         </p:nvSpPr>
         <p:spPr>
           <a:xfrm>
-            <a:off x="868680" y="2194560"/>
-            <a:ext cx="1234440" cy="411480"/>
+            <a:off x="868680" y="2148840"/>
+            <a:ext cx="1234440" cy="365760"/>
           </a:xfrm>
           <a:prstGeom prst="rect">
             <a:avLst/>
@@ -10814,7 +10814,7 @@
         <p:spPr>
           <a:xfrm>
             <a:off x="2194560" y="1920240"/>
-            <a:ext cx="2926080" cy="960120"/>
+            <a:ext cx="2926080" cy="822960"/>
           </a:xfrm>
           <a:prstGeom prst="roundRect">
             <a:avLst>
@@ -10861,7 +10861,7 @@
         <p:spPr>
           <a:xfrm>
             <a:off x="2194560" y="1920240"/>
-            <a:ext cx="50800" cy="960120"/>
+            <a:ext cx="50800" cy="822960"/>
           </a:xfrm>
           <a:prstGeom prst="rect">
             <a:avLst/>
@@ -10939,7 +10939,7 @@
         </p:nvSpPr>
         <p:spPr>
           <a:xfrm>
-            <a:off x="2377440" y="2194560"/>
+            <a:off x="2377440" y="2148840"/>
             <a:ext cx="2560320" cy="274320"/>
           </a:xfrm>
           <a:prstGeom prst="rect">
@@ -10954,7 +10954,7 @@
           <a:lstStyle/>
           <a:p>
             <a:pPr algn="l">
-              <a:defRPr sz="1300" b="1" i="0">
+              <a:defRPr sz="1200" b="1" i="0">
                 <a:solidFill>
                   <a:srgbClr val="1C1C1E"/>
                 </a:solidFill>
@@ -10975,22 +10975,22 @@
         </p:nvSpPr>
         <p:spPr>
           <a:xfrm>
-            <a:off x="2377440" y="2514600"/>
-            <a:ext cx="2560320" cy="320040"/>
-          </a:xfrm>
-          <a:prstGeom prst="rect">
-            <a:avLst/>
-          </a:prstGeom>
-          <a:noFill/>
-        </p:spPr>
-        <p:txBody>
-          <a:bodyPr wrap="square">
-            <a:spAutoFit/>
-          </a:bodyPr>
-          <a:lstStyle/>
-          <a:p>
-            <a:pPr algn="l">
-              <a:defRPr sz="1000" b="0" i="0">
+            <a:off x="2377440" y="2423160"/>
+            <a:ext cx="2560320" cy="274320"/>
+          </a:xfrm>
+          <a:prstGeom prst="rect">
+            <a:avLst/>
+          </a:prstGeom>
+          <a:noFill/>
+        </p:spPr>
+        <p:txBody>
+          <a:bodyPr wrap="square">
+            <a:spAutoFit/>
+          </a:bodyPr>
+          <a:lstStyle/>
+          <a:p>
+            <a:pPr algn="l">
+              <a:defRPr sz="900" b="0" i="0">
                 <a:solidFill>
                   <a:srgbClr val="767676"/>
                 </a:solidFill>
@@ -11012,7 +11012,7 @@
         <p:spPr>
           <a:xfrm>
             <a:off x="5257800" y="1920240"/>
-            <a:ext cx="2926080" cy="960120"/>
+            <a:ext cx="2926080" cy="822960"/>
           </a:xfrm>
           <a:prstGeom prst="roundRect">
             <a:avLst>
@@ -11058,7 +11058,7 @@
         </p:nvSpPr>
         <p:spPr>
           <a:xfrm>
-            <a:off x="5440680" y="2194560"/>
+            <a:off x="5440680" y="2148840"/>
             <a:ext cx="2560320" cy="274320"/>
           </a:xfrm>
           <a:prstGeom prst="rect">
@@ -11073,7 +11073,7 @@
           <a:lstStyle/>
           <a:p>
             <a:pPr algn="l">
-              <a:defRPr sz="1300" b="1" i="0">
+              <a:defRPr sz="1200" b="1" i="0">
                 <a:solidFill>
                   <a:srgbClr val="1C1C1E"/>
                 </a:solidFill>
@@ -11094,22 +11094,22 @@
         </p:nvSpPr>
         <p:spPr>
           <a:xfrm>
-            <a:off x="5440680" y="2514600"/>
-            <a:ext cx="2560320" cy="320040"/>
-          </a:xfrm>
-          <a:prstGeom prst="rect">
-            <a:avLst/>
-          </a:prstGeom>
-          <a:noFill/>
-        </p:spPr>
-        <p:txBody>
-          <a:bodyPr wrap="square">
-            <a:spAutoFit/>
-          </a:bodyPr>
-          <a:lstStyle/>
-          <a:p>
-            <a:pPr algn="l">
-              <a:defRPr sz="1000" b="0" i="0">
+            <a:off x="5440680" y="2423160"/>
+            <a:ext cx="2560320" cy="274320"/>
+          </a:xfrm>
+          <a:prstGeom prst="rect">
+            <a:avLst/>
+          </a:prstGeom>
+          <a:noFill/>
+        </p:spPr>
+        <p:txBody>
+          <a:bodyPr wrap="square">
+            <a:spAutoFit/>
+          </a:bodyPr>
+          <a:lstStyle/>
+          <a:p>
+            <a:pPr algn="l">
+              <a:defRPr sz="900" b="0" i="0">
                 <a:solidFill>
                   <a:srgbClr val="767676"/>
                 </a:solidFill>
@@ -11131,7 +11131,7 @@
         <p:spPr>
           <a:xfrm>
             <a:off x="8321040" y="1920240"/>
-            <a:ext cx="2926080" cy="960120"/>
+            <a:ext cx="2926080" cy="822960"/>
           </a:xfrm>
           <a:prstGeom prst="roundRect">
             <a:avLst>
@@ -11177,7 +11177,7 @@
         </p:nvSpPr>
         <p:spPr>
           <a:xfrm>
-            <a:off x="8503920" y="2194560"/>
+            <a:off x="8503920" y="2148840"/>
             <a:ext cx="2560320" cy="274320"/>
           </a:xfrm>
           <a:prstGeom prst="rect">
@@ -11192,7 +11192,7 @@
           <a:lstStyle/>
           <a:p>
             <a:pPr algn="l">
-              <a:defRPr sz="1300" b="1" i="0">
+              <a:defRPr sz="1200" b="1" i="0">
                 <a:solidFill>
                   <a:srgbClr val="1C1C1E"/>
                 </a:solidFill>
@@ -11213,22 +11213,22 @@
         </p:nvSpPr>
         <p:spPr>
           <a:xfrm>
-            <a:off x="8503920" y="2514600"/>
-            <a:ext cx="2560320" cy="320040"/>
-          </a:xfrm>
-          <a:prstGeom prst="rect">
-            <a:avLst/>
-          </a:prstGeom>
-          <a:noFill/>
-        </p:spPr>
-        <p:txBody>
-          <a:bodyPr wrap="square">
-            <a:spAutoFit/>
-          </a:bodyPr>
-          <a:lstStyle/>
-          <a:p>
-            <a:pPr algn="l">
-              <a:defRPr sz="1000" b="0" i="0">
+            <a:off x="8503920" y="2423160"/>
+            <a:ext cx="2560320" cy="274320"/>
+          </a:xfrm>
+          <a:prstGeom prst="rect">
+            <a:avLst/>
+          </a:prstGeom>
+          <a:noFill/>
+        </p:spPr>
+        <p:txBody>
+          <a:bodyPr wrap="square">
+            <a:spAutoFit/>
+          </a:bodyPr>
+          <a:lstStyle/>
+          <a:p>
+            <a:pPr algn="l">
+              <a:defRPr sz="900" b="0" i="0">
                 <a:solidFill>
                   <a:srgbClr val="767676"/>
                 </a:solidFill>
@@ -11249,8 +11249,8 @@
         </p:nvSpPr>
         <p:spPr>
           <a:xfrm>
-            <a:off x="731520" y="3017520"/>
-            <a:ext cx="50800" cy="960120"/>
+            <a:off x="731520" y="3154680"/>
+            <a:ext cx="50800" cy="822960"/>
           </a:xfrm>
           <a:prstGeom prst="rect">
             <a:avLst/>
@@ -11292,8 +11292,8 @@
         </p:nvSpPr>
         <p:spPr>
           <a:xfrm>
-            <a:off x="868680" y="3291840"/>
-            <a:ext cx="1234440" cy="411480"/>
+            <a:off x="868680" y="3383280"/>
+            <a:ext cx="1234440" cy="365760"/>
           </a:xfrm>
           <a:prstGeom prst="rect">
             <a:avLst/>
@@ -11328,8 +11328,8 @@
         </p:nvSpPr>
         <p:spPr>
           <a:xfrm>
-            <a:off x="2194560" y="3017520"/>
-            <a:ext cx="2926080" cy="960120"/>
+            <a:off x="2194560" y="3154680"/>
+            <a:ext cx="2926080" cy="822960"/>
           </a:xfrm>
           <a:prstGeom prst="roundRect">
             <a:avLst>
@@ -11375,7 +11375,7 @@
         </p:nvSpPr>
         <p:spPr>
           <a:xfrm>
-            <a:off x="2377440" y="3291840"/>
+            <a:off x="2377440" y="3383280"/>
             <a:ext cx="2560320" cy="274320"/>
           </a:xfrm>
           <a:prstGeom prst="rect">
@@ -11390,7 +11390,7 @@
           <a:lstStyle/>
           <a:p>
             <a:pPr algn="l">
-              <a:defRPr sz="1300" b="1" i="0">
+              <a:defRPr sz="1200" b="1" i="0">
                 <a:solidFill>
                   <a:srgbClr val="1C1C1E"/>
                 </a:solidFill>
@@ -11411,22 +11411,22 @@
         </p:nvSpPr>
         <p:spPr>
           <a:xfrm>
-            <a:off x="2377440" y="3611880"/>
-            <a:ext cx="2560320" cy="320040"/>
-          </a:xfrm>
-          <a:prstGeom prst="rect">
-            <a:avLst/>
-          </a:prstGeom>
-          <a:noFill/>
-        </p:spPr>
-        <p:txBody>
-          <a:bodyPr wrap="square">
-            <a:spAutoFit/>
-          </a:bodyPr>
-          <a:lstStyle/>
-          <a:p>
-            <a:pPr algn="l">
-              <a:defRPr sz="1000" b="0" i="0">
+            <a:off x="2377440" y="3657600"/>
+            <a:ext cx="2560320" cy="274320"/>
+          </a:xfrm>
+          <a:prstGeom prst="rect">
+            <a:avLst/>
+          </a:prstGeom>
+          <a:noFill/>
+        </p:spPr>
+        <p:txBody>
+          <a:bodyPr wrap="square">
+            <a:spAutoFit/>
+          </a:bodyPr>
+          <a:lstStyle/>
+          <a:p>
+            <a:pPr algn="l">
+              <a:defRPr sz="900" b="0" i="0">
                 <a:solidFill>
                   <a:srgbClr val="767676"/>
                 </a:solidFill>
@@ -11447,8 +11447,8 @@
         </p:nvSpPr>
         <p:spPr>
           <a:xfrm>
-            <a:off x="5257800" y="3017520"/>
-            <a:ext cx="2926080" cy="960120"/>
+            <a:off x="5257800" y="3154680"/>
+            <a:ext cx="2926080" cy="822960"/>
           </a:xfrm>
           <a:prstGeom prst="roundRect">
             <a:avLst>
@@ -11494,7 +11494,7 @@
         </p:nvSpPr>
         <p:spPr>
           <a:xfrm>
-            <a:off x="5440680" y="3291840"/>
+            <a:off x="5440680" y="3383280"/>
             <a:ext cx="2560320" cy="274320"/>
           </a:xfrm>
           <a:prstGeom prst="rect">
@@ -11509,7 +11509,7 @@
           <a:lstStyle/>
           <a:p>
             <a:pPr algn="l">
-              <a:defRPr sz="1300" b="1" i="0">
+              <a:defRPr sz="1200" b="1" i="0">
                 <a:solidFill>
                   <a:srgbClr val="1C1C1E"/>
                 </a:solidFill>
@@ -11530,22 +11530,22 @@
         </p:nvSpPr>
         <p:spPr>
           <a:xfrm>
-            <a:off x="5440680" y="3611880"/>
-            <a:ext cx="2560320" cy="320040"/>
-          </a:xfrm>
-          <a:prstGeom prst="rect">
-            <a:avLst/>
-          </a:prstGeom>
-          <a:noFill/>
-        </p:spPr>
-        <p:txBody>
-          <a:bodyPr wrap="square">
-            <a:spAutoFit/>
-          </a:bodyPr>
-          <a:lstStyle/>
-          <a:p>
-            <a:pPr algn="l">
-              <a:defRPr sz="1000" b="0" i="0">
+            <a:off x="5440680" y="3657600"/>
+            <a:ext cx="2560320" cy="274320"/>
+          </a:xfrm>
+          <a:prstGeom prst="rect">
+            <a:avLst/>
+          </a:prstGeom>
+          <a:noFill/>
+        </p:spPr>
+        <p:txBody>
+          <a:bodyPr wrap="square">
+            <a:spAutoFit/>
+          </a:bodyPr>
+          <a:lstStyle/>
+          <a:p>
+            <a:pPr algn="l">
+              <a:defRPr sz="900" b="0" i="0">
                 <a:solidFill>
                   <a:srgbClr val="767676"/>
                 </a:solidFill>
@@ -11566,8 +11566,8 @@
         </p:nvSpPr>
         <p:spPr>
           <a:xfrm>
-            <a:off x="8321040" y="3017520"/>
-            <a:ext cx="2926080" cy="960120"/>
+            <a:off x="8321040" y="3154680"/>
+            <a:ext cx="2926080" cy="822960"/>
           </a:xfrm>
           <a:prstGeom prst="roundRect">
             <a:avLst>
@@ -11613,7 +11613,7 @@
         </p:nvSpPr>
         <p:spPr>
           <a:xfrm>
-            <a:off x="8503920" y="3291840"/>
+            <a:off x="8503920" y="3383280"/>
             <a:ext cx="2560320" cy="274320"/>
           </a:xfrm>
           <a:prstGeom prst="rect">
@@ -11628,7 +11628,7 @@
           <a:lstStyle/>
           <a:p>
             <a:pPr algn="l">
-              <a:defRPr sz="1300" b="1" i="0">
+              <a:defRPr sz="1200" b="1" i="0">
                 <a:solidFill>
                   <a:srgbClr val="1C1C1E"/>
                 </a:solidFill>
@@ -11649,22 +11649,22 @@
         </p:nvSpPr>
         <p:spPr>
           <a:xfrm>
-            <a:off x="8503920" y="3611880"/>
-            <a:ext cx="2560320" cy="320040"/>
-          </a:xfrm>
-          <a:prstGeom prst="rect">
-            <a:avLst/>
-          </a:prstGeom>
-          <a:noFill/>
-        </p:spPr>
-        <p:txBody>
-          <a:bodyPr wrap="square">
-            <a:spAutoFit/>
-          </a:bodyPr>
-          <a:lstStyle/>
-          <a:p>
-            <a:pPr algn="l">
-              <a:defRPr sz="1000" b="0" i="0">
+            <a:off x="8503920" y="3657600"/>
+            <a:ext cx="2560320" cy="274320"/>
+          </a:xfrm>
+          <a:prstGeom prst="rect">
+            <a:avLst/>
+          </a:prstGeom>
+          <a:noFill/>
+        </p:spPr>
+        <p:txBody>
+          <a:bodyPr wrap="square">
+            <a:spAutoFit/>
+          </a:bodyPr>
+          <a:lstStyle/>
+          <a:p>
+            <a:pPr algn="l">
+              <a:defRPr sz="900" b="0" i="0">
                 <a:solidFill>
                   <a:srgbClr val="767676"/>
                 </a:solidFill>
@@ -11685,8 +11685,8 @@
         </p:nvSpPr>
         <p:spPr>
           <a:xfrm>
-            <a:off x="731520" y="4114800"/>
-            <a:ext cx="50800" cy="960120"/>
+            <a:off x="731520" y="4069080"/>
+            <a:ext cx="50800" cy="822960"/>
           </a:xfrm>
           <a:prstGeom prst="rect">
             <a:avLst/>
@@ -11728,8 +11728,8 @@
         </p:nvSpPr>
         <p:spPr>
           <a:xfrm>
-            <a:off x="868680" y="4389120"/>
-            <a:ext cx="1234440" cy="411480"/>
+            <a:off x="868680" y="4297680"/>
+            <a:ext cx="1234440" cy="365760"/>
           </a:xfrm>
           <a:prstGeom prst="rect">
             <a:avLst/>
@@ -11764,8 +11764,8 @@
         </p:nvSpPr>
         <p:spPr>
           <a:xfrm>
-            <a:off x="2194560" y="4114800"/>
-            <a:ext cx="2926080" cy="960120"/>
+            <a:off x="2194560" y="4069080"/>
+            <a:ext cx="2926080" cy="822960"/>
           </a:xfrm>
           <a:prstGeom prst="roundRect">
             <a:avLst>
@@ -11811,7 +11811,7 @@
         </p:nvSpPr>
         <p:spPr>
           <a:xfrm>
-            <a:off x="2377440" y="4389120"/>
+            <a:off x="2377440" y="4297680"/>
             <a:ext cx="2560320" cy="274320"/>
           </a:xfrm>
           <a:prstGeom prst="rect">
@@ -11826,7 +11826,7 @@
           <a:lstStyle/>
           <a:p>
             <a:pPr algn="l">
-              <a:defRPr sz="1300" b="1" i="0">
+              <a:defRPr sz="1200" b="1" i="0">
                 <a:solidFill>
                   <a:srgbClr val="1C1C1E"/>
                 </a:solidFill>
@@ -11847,22 +11847,22 @@
         </p:nvSpPr>
         <p:spPr>
           <a:xfrm>
-            <a:off x="2377440" y="4709160"/>
-            <a:ext cx="2560320" cy="320040"/>
-          </a:xfrm>
-          <a:prstGeom prst="rect">
-            <a:avLst/>
-          </a:prstGeom>
-          <a:noFill/>
-        </p:spPr>
-        <p:txBody>
-          <a:bodyPr wrap="square">
-            <a:spAutoFit/>
-          </a:bodyPr>
-          <a:lstStyle/>
-          <a:p>
-            <a:pPr algn="l">
-              <a:defRPr sz="1000" b="0" i="0">
+            <a:off x="2377440" y="4572000"/>
+            <a:ext cx="2560320" cy="274320"/>
+          </a:xfrm>
+          <a:prstGeom prst="rect">
+            <a:avLst/>
+          </a:prstGeom>
+          <a:noFill/>
+        </p:spPr>
+        <p:txBody>
+          <a:bodyPr wrap="square">
+            <a:spAutoFit/>
+          </a:bodyPr>
+          <a:lstStyle/>
+          <a:p>
+            <a:pPr algn="l">
+              <a:defRPr sz="900" b="0" i="0">
                 <a:solidFill>
                   <a:srgbClr val="767676"/>
                 </a:solidFill>
@@ -11883,8 +11883,8 @@
         </p:nvSpPr>
         <p:spPr>
           <a:xfrm>
-            <a:off x="5257800" y="4114800"/>
-            <a:ext cx="2926080" cy="960120"/>
+            <a:off x="5257800" y="4069080"/>
+            <a:ext cx="2926080" cy="822960"/>
           </a:xfrm>
           <a:prstGeom prst="roundRect">
             <a:avLst>
@@ -11930,7 +11930,7 @@
         </p:nvSpPr>
         <p:spPr>
           <a:xfrm>
-            <a:off x="5440680" y="4389120"/>
+            <a:off x="5440680" y="4297680"/>
             <a:ext cx="2560320" cy="274320"/>
           </a:xfrm>
           <a:prstGeom prst="rect">
@@ -11945,7 +11945,7 @@
           <a:lstStyle/>
           <a:p>
             <a:pPr algn="l">
-              <a:defRPr sz="1300" b="1" i="0">
+              <a:defRPr sz="1200" b="1" i="0">
                 <a:solidFill>
                   <a:srgbClr val="1C1C1E"/>
                 </a:solidFill>
@@ -11966,22 +11966,22 @@
         </p:nvSpPr>
         <p:spPr>
           <a:xfrm>
-            <a:off x="5440680" y="4709160"/>
-            <a:ext cx="2560320" cy="320040"/>
-          </a:xfrm>
-          <a:prstGeom prst="rect">
-            <a:avLst/>
-          </a:prstGeom>
-          <a:noFill/>
-        </p:spPr>
-        <p:txBody>
-          <a:bodyPr wrap="square">
-            <a:spAutoFit/>
-          </a:bodyPr>
-          <a:lstStyle/>
-          <a:p>
-            <a:pPr algn="l">
-              <a:defRPr sz="1000" b="0" i="0">
+            <a:off x="5440680" y="4572000"/>
+            <a:ext cx="2560320" cy="274320"/>
+          </a:xfrm>
+          <a:prstGeom prst="rect">
+            <a:avLst/>
+          </a:prstGeom>
+          <a:noFill/>
+        </p:spPr>
+        <p:txBody>
+          <a:bodyPr wrap="square">
+            <a:spAutoFit/>
+          </a:bodyPr>
+          <a:lstStyle/>
+          <a:p>
+            <a:pPr algn="l">
+              <a:defRPr sz="900" b="0" i="0">
                 <a:solidFill>
                   <a:srgbClr val="767676"/>
                 </a:solidFill>
@@ -12002,8 +12002,8 @@
         </p:nvSpPr>
         <p:spPr>
           <a:xfrm>
-            <a:off x="8321040" y="4114800"/>
-            <a:ext cx="2926080" cy="960120"/>
+            <a:off x="8321040" y="4069080"/>
+            <a:ext cx="2926080" cy="822960"/>
           </a:xfrm>
           <a:prstGeom prst="roundRect">
             <a:avLst>
@@ -12049,7 +12049,7 @@
         </p:nvSpPr>
         <p:spPr>
           <a:xfrm>
-            <a:off x="8503920" y="4389120"/>
+            <a:off x="8503920" y="4297680"/>
             <a:ext cx="2560320" cy="274320"/>
           </a:xfrm>
           <a:prstGeom prst="rect">
@@ -12064,7 +12064,7 @@
           <a:lstStyle/>
           <a:p>
             <a:pPr algn="l">
-              <a:defRPr sz="1300" b="1" i="0">
+              <a:defRPr sz="1200" b="1" i="0">
                 <a:solidFill>
                   <a:srgbClr val="1C1C1E"/>
                 </a:solidFill>
@@ -12085,22 +12085,22 @@
         </p:nvSpPr>
         <p:spPr>
           <a:xfrm>
-            <a:off x="8503920" y="4709160"/>
-            <a:ext cx="2560320" cy="320040"/>
-          </a:xfrm>
-          <a:prstGeom prst="rect">
-            <a:avLst/>
-          </a:prstGeom>
-          <a:noFill/>
-        </p:spPr>
-        <p:txBody>
-          <a:bodyPr wrap="square">
-            <a:spAutoFit/>
-          </a:bodyPr>
-          <a:lstStyle/>
-          <a:p>
-            <a:pPr algn="l">
-              <a:defRPr sz="1000" b="0" i="0">
+            <a:off x="8503920" y="4572000"/>
+            <a:ext cx="2560320" cy="274320"/>
+          </a:xfrm>
+          <a:prstGeom prst="rect">
+            <a:avLst/>
+          </a:prstGeom>
+          <a:noFill/>
+        </p:spPr>
+        <p:txBody>
+          <a:bodyPr wrap="square">
+            <a:spAutoFit/>
+          </a:bodyPr>
+          <a:lstStyle/>
+          <a:p>
+            <a:pPr algn="l">
+              <a:defRPr sz="900" b="0" i="0">
                 <a:solidFill>
                   <a:srgbClr val="767676"/>
                 </a:solidFill>
@@ -12121,8 +12121,8 @@
         </p:nvSpPr>
         <p:spPr>
           <a:xfrm>
-            <a:off x="731520" y="5212079"/>
-            <a:ext cx="50800" cy="960120"/>
+            <a:off x="731520" y="4983480"/>
+            <a:ext cx="50800" cy="822960"/>
           </a:xfrm>
           <a:prstGeom prst="rect">
             <a:avLst/>
@@ -12164,8 +12164,8 @@
         </p:nvSpPr>
         <p:spPr>
           <a:xfrm>
-            <a:off x="868680" y="5486399"/>
-            <a:ext cx="1234440" cy="411480"/>
+            <a:off x="868680" y="5212080"/>
+            <a:ext cx="1234440" cy="365760"/>
           </a:xfrm>
           <a:prstGeom prst="rect">
             <a:avLst/>
@@ -12200,8 +12200,8 @@
         </p:nvSpPr>
         <p:spPr>
           <a:xfrm>
-            <a:off x="2194560" y="5212079"/>
-            <a:ext cx="2926080" cy="960120"/>
+            <a:off x="2194560" y="4983480"/>
+            <a:ext cx="2926080" cy="822960"/>
           </a:xfrm>
           <a:prstGeom prst="roundRect">
             <a:avLst>
@@ -12247,7 +12247,7 @@
         </p:nvSpPr>
         <p:spPr>
           <a:xfrm>
-            <a:off x="2377440" y="5486399"/>
+            <a:off x="2377440" y="5212080"/>
             <a:ext cx="2560320" cy="274320"/>
           </a:xfrm>
           <a:prstGeom prst="rect">
@@ -12262,7 +12262,7 @@
           <a:lstStyle/>
           <a:p>
             <a:pPr algn="l">
-              <a:defRPr sz="1300" b="1" i="0">
+              <a:defRPr sz="1200" b="1" i="0">
                 <a:solidFill>
                   <a:srgbClr val="1C1C1E"/>
                 </a:solidFill>
@@ -12283,22 +12283,22 @@
         </p:nvSpPr>
         <p:spPr>
           <a:xfrm>
-            <a:off x="2377440" y="5806439"/>
-            <a:ext cx="2560320" cy="320040"/>
-          </a:xfrm>
-          <a:prstGeom prst="rect">
-            <a:avLst/>
-          </a:prstGeom>
-          <a:noFill/>
-        </p:spPr>
-        <p:txBody>
-          <a:bodyPr wrap="square">
-            <a:spAutoFit/>
-          </a:bodyPr>
-          <a:lstStyle/>
-          <a:p>
-            <a:pPr algn="l">
-              <a:defRPr sz="1000" b="0" i="0">
+            <a:off x="2377440" y="5486400"/>
+            <a:ext cx="2560320" cy="274320"/>
+          </a:xfrm>
+          <a:prstGeom prst="rect">
+            <a:avLst/>
+          </a:prstGeom>
+          <a:noFill/>
+        </p:spPr>
+        <p:txBody>
+          <a:bodyPr wrap="square">
+            <a:spAutoFit/>
+          </a:bodyPr>
+          <a:lstStyle/>
+          <a:p>
+            <a:pPr algn="l">
+              <a:defRPr sz="900" b="0" i="0">
                 <a:solidFill>
                   <a:srgbClr val="767676"/>
                 </a:solidFill>
@@ -12319,8 +12319,8 @@
         </p:nvSpPr>
         <p:spPr>
           <a:xfrm>
-            <a:off x="5257800" y="5212079"/>
-            <a:ext cx="2926080" cy="960120"/>
+            <a:off x="5257800" y="4983480"/>
+            <a:ext cx="2926080" cy="822960"/>
           </a:xfrm>
           <a:prstGeom prst="roundRect">
             <a:avLst>
@@ -12366,7 +12366,7 @@
         </p:nvSpPr>
         <p:spPr>
           <a:xfrm>
-            <a:off x="5440680" y="5486399"/>
+            <a:off x="5440680" y="5212080"/>
             <a:ext cx="2560320" cy="274320"/>
           </a:xfrm>
           <a:prstGeom prst="rect">
@@ -12381,7 +12381,7 @@
           <a:lstStyle/>
           <a:p>
             <a:pPr algn="l">
-              <a:defRPr sz="1300" b="1" i="0">
+              <a:defRPr sz="1200" b="1" i="0">
                 <a:solidFill>
                   <a:srgbClr val="1C1C1E"/>
                 </a:solidFill>
@@ -12402,22 +12402,22 @@
         </p:nvSpPr>
         <p:spPr>
           <a:xfrm>
-            <a:off x="5440680" y="5806439"/>
-            <a:ext cx="2560320" cy="320040"/>
-          </a:xfrm>
-          <a:prstGeom prst="rect">
-            <a:avLst/>
-          </a:prstGeom>
-          <a:noFill/>
-        </p:spPr>
-        <p:txBody>
-          <a:bodyPr wrap="square">
-            <a:spAutoFit/>
-          </a:bodyPr>
-          <a:lstStyle/>
-          <a:p>
-            <a:pPr algn="l">
-              <a:defRPr sz="1000" b="0" i="0">
+            <a:off x="5440680" y="5486400"/>
+            <a:ext cx="2560320" cy="274320"/>
+          </a:xfrm>
+          <a:prstGeom prst="rect">
+            <a:avLst/>
+          </a:prstGeom>
+          <a:noFill/>
+        </p:spPr>
+        <p:txBody>
+          <a:bodyPr wrap="square">
+            <a:spAutoFit/>
+          </a:bodyPr>
+          <a:lstStyle/>
+          <a:p>
+            <a:pPr algn="l">
+              <a:defRPr sz="900" b="0" i="0">
                 <a:solidFill>
                   <a:srgbClr val="767676"/>
                 </a:solidFill>
@@ -12438,8 +12438,8 @@
         </p:nvSpPr>
         <p:spPr>
           <a:xfrm>
-            <a:off x="8321040" y="5212079"/>
-            <a:ext cx="2926080" cy="960120"/>
+            <a:off x="8321040" y="4983480"/>
+            <a:ext cx="2926080" cy="822960"/>
           </a:xfrm>
           <a:prstGeom prst="roundRect">
             <a:avLst>
@@ -12485,7 +12485,7 @@
         </p:nvSpPr>
         <p:spPr>
           <a:xfrm>
-            <a:off x="8503920" y="5486399"/>
+            <a:off x="8503920" y="5212080"/>
             <a:ext cx="2560320" cy="274320"/>
           </a:xfrm>
           <a:prstGeom prst="rect">
@@ -12500,7 +12500,7 @@
           <a:lstStyle/>
           <a:p>
             <a:pPr algn="l">
-              <a:defRPr sz="1300" b="1" i="0">
+              <a:defRPr sz="1200" b="1" i="0">
                 <a:solidFill>
                   <a:srgbClr val="1C1C1E"/>
                 </a:solidFill>
@@ -12521,22 +12521,22 @@
         </p:nvSpPr>
         <p:spPr>
           <a:xfrm>
-            <a:off x="8503920" y="5806439"/>
-            <a:ext cx="2560320" cy="320040"/>
-          </a:xfrm>
-          <a:prstGeom prst="rect">
-            <a:avLst/>
-          </a:prstGeom>
-          <a:noFill/>
-        </p:spPr>
-        <p:txBody>
-          <a:bodyPr wrap="square">
-            <a:spAutoFit/>
-          </a:bodyPr>
-          <a:lstStyle/>
-          <a:p>
-            <a:pPr algn="l">
-              <a:defRPr sz="1000" b="0" i="0">
+            <a:off x="8503920" y="5486400"/>
+            <a:ext cx="2560320" cy="274320"/>
+          </a:xfrm>
+          <a:prstGeom prst="rect">
+            <a:avLst/>
+          </a:prstGeom>
+          <a:noFill/>
+        </p:spPr>
+        <p:txBody>
+          <a:bodyPr wrap="square">
+            <a:spAutoFit/>
+          </a:bodyPr>
+          <a:lstStyle/>
+          <a:p>
+            <a:pPr algn="l">
+              <a:defRPr sz="900" b="0" i="0">
                 <a:solidFill>
                   <a:srgbClr val="767676"/>
                 </a:solidFill>
@@ -12551,7 +12551,122 @@
       </p:sp>
       <p:sp>
         <p:nvSpPr>
-          <p:cNvPr id="57" name="Oval 56"/>
+          <p:cNvPr id="57" name="Rectangle 56"/>
+          <p:cNvSpPr/>
+          <p:nvPr/>
+        </p:nvSpPr>
+        <p:spPr>
+          <a:xfrm>
+            <a:off x="594360" y="1847088"/>
+            <a:ext cx="10927080" cy="969264"/>
+          </a:xfrm>
+          <a:prstGeom prst="rect">
+            <a:avLst/>
+          </a:prstGeom>
+          <a:noFill/>
+          <a:ln w="31750">
+            <a:solidFill>
+              <a:srgbClr val="2D5F8A"/>
+            </a:solidFill>
+          </a:ln>
+        </p:spPr>
+        <p:style>
+          <a:lnRef idx="1">
+            <a:schemeClr val="accent1"/>
+          </a:lnRef>
+          <a:fillRef idx="3">
+            <a:schemeClr val="accent1"/>
+          </a:fillRef>
+          <a:effectRef idx="2">
+            <a:schemeClr val="accent1"/>
+          </a:effectRef>
+          <a:fontRef idx="minor">
+            <a:schemeClr val="lt1"/>
+          </a:fontRef>
+        </p:style>
+        <p:txBody>
+          <a:bodyPr rtlCol="0" anchor="ctr"/>
+          <a:lstStyle/>
+          <a:p>
+            <a:pPr algn="ctr"/>
+          </a:p>
+        </p:txBody>
+      </p:sp>
+      <p:sp>
+        <p:nvSpPr>
+          <p:cNvPr id="58" name="TextBox 57"/>
+          <p:cNvSpPr txBox="1"/>
+          <p:nvPr/>
+        </p:nvSpPr>
+        <p:spPr>
+          <a:xfrm>
+            <a:off x="9784080" y="1627632"/>
+            <a:ext cx="1645920" cy="201168"/>
+          </a:xfrm>
+          <a:prstGeom prst="rect">
+            <a:avLst/>
+          </a:prstGeom>
+          <a:noFill/>
+        </p:spPr>
+        <p:txBody>
+          <a:bodyPr wrap="square">
+            <a:spAutoFit/>
+          </a:bodyPr>
+          <a:lstStyle/>
+          <a:p>
+            <a:pPr algn="r">
+              <a:defRPr sz="1000" b="1" i="0">
+                <a:solidFill>
+                  <a:srgbClr val="2D5F8A"/>
+                </a:solidFill>
+                <a:latin typeface="Calibri"/>
+              </a:defRPr>
+            </a:pPr>
+            <a:r>
+              <a:t>START HERE</a:t>
+            </a:r>
+          </a:p>
+        </p:txBody>
+      </p:sp>
+      <p:sp>
+        <p:nvSpPr>
+          <p:cNvPr id="59" name="TextBox 58"/>
+          <p:cNvSpPr txBox="1"/>
+          <p:nvPr/>
+        </p:nvSpPr>
+        <p:spPr>
+          <a:xfrm>
+            <a:off x="2194560" y="2852928"/>
+            <a:ext cx="9144000" cy="201168"/>
+          </a:xfrm>
+          <a:prstGeom prst="rect">
+            <a:avLst/>
+          </a:prstGeom>
+          <a:noFill/>
+        </p:spPr>
+        <p:txBody>
+          <a:bodyPr wrap="square">
+            <a:spAutoFit/>
+          </a:bodyPr>
+          <a:lstStyle/>
+          <a:p>
+            <a:pPr algn="l">
+              <a:defRPr sz="900" b="0" i="0">
+                <a:solidFill>
+                  <a:srgbClr val="2D5F8A"/>
+                </a:solidFill>
+                <a:latin typeface="Calibri"/>
+              </a:defRPr>
+            </a:pPr>
+            <a:r>
+              <a:t>Support tasks are measurable, well-defined, and understood. AI quality is easy to verify when domain knowledge is high.</a:t>
+            </a:r>
+          </a:p>
+        </p:txBody>
+      </p:sp>
+      <p:sp>
+        <p:nvSpPr>
+          <p:cNvPr id="60" name="Oval 59"/>
           <p:cNvSpPr/>
           <p:nvPr/>
         </p:nvSpPr>
@@ -12594,7 +12709,7 @@
       </p:sp>
       <p:sp>
         <p:nvSpPr>
-          <p:cNvPr id="58" name="TextBox 57"/>
+          <p:cNvPr id="61" name="TextBox 60"/>
           <p:cNvSpPr txBox="1"/>
           <p:nvPr/>
         </p:nvSpPr>
@@ -12630,7 +12745,7 @@
       </p:sp>
       <p:sp>
         <p:nvSpPr>
-          <p:cNvPr id="59" name="Oval 58"/>
+          <p:cNvPr id="62" name="Oval 61"/>
           <p:cNvSpPr/>
           <p:nvPr/>
         </p:nvSpPr>
@@ -12673,7 +12788,7 @@
       </p:sp>
       <p:sp>
         <p:nvSpPr>
-          <p:cNvPr id="60" name="TextBox 59"/>
+          <p:cNvPr id="63" name="TextBox 62"/>
           <p:cNvSpPr txBox="1"/>
           <p:nvPr/>
         </p:nvSpPr>
@@ -12709,7 +12824,7 @@
       </p:sp>
       <p:sp>
         <p:nvSpPr>
-          <p:cNvPr id="61" name="Oval 60"/>
+          <p:cNvPr id="64" name="Oval 63"/>
           <p:cNvSpPr/>
           <p:nvPr/>
         </p:nvSpPr>
@@ -12752,7 +12867,7 @@
       </p:sp>
       <p:sp>
         <p:nvSpPr>
-          <p:cNvPr id="62" name="TextBox 61"/>
+          <p:cNvPr id="65" name="TextBox 64"/>
           <p:cNvSpPr txBox="1"/>
           <p:nvPr/>
         </p:nvSpPr>
@@ -12788,7 +12903,7 @@
       </p:sp>
       <p:sp>
         <p:nvSpPr>
-          <p:cNvPr id="63" name="Oval 62"/>
+          <p:cNvPr id="66" name="Oval 65"/>
           <p:cNvSpPr/>
           <p:nvPr/>
         </p:nvSpPr>
@@ -12831,7 +12946,7 @@
       </p:sp>
       <p:sp>
         <p:nvSpPr>
-          <p:cNvPr id="64" name="TextBox 63"/>
+          <p:cNvPr id="67" name="TextBox 66"/>
           <p:cNvSpPr txBox="1"/>
           <p:nvPr/>
         </p:nvSpPr>
@@ -12867,7 +12982,7 @@
       </p:sp>
       <p:sp>
         <p:nvSpPr>
-          <p:cNvPr id="65" name="TextBox 64"/>
+          <p:cNvPr id="68" name="TextBox 67"/>
           <p:cNvSpPr txBox="1"/>
           <p:nvPr/>
         </p:nvSpPr>
@@ -12903,7 +13018,7 @@
       </p:sp>
       <p:sp>
         <p:nvSpPr>
-          <p:cNvPr id="66" name="TextBox 65"/>
+          <p:cNvPr id="69" name="TextBox 68"/>
           <p:cNvSpPr txBox="1"/>
           <p:nvPr/>
         </p:nvSpPr>
@@ -21433,7 +21548,7 @@
               </a:defRPr>
             </a:pPr>
             <a:r>
-              <a:t>Each connected SRAM product a rider buys increases the value of the data and the quality of the AI. No competitor can replicate this full-stack advantage.</a:t>
+              <a:t>Proven AI pilots, strong data infrastructure, and teams that understand guardrails unlock the innovation no competitor can replicate.</a:t>
             </a:r>
           </a:p>
         </p:txBody>
@@ -22212,7 +22327,205 @@
         <p:spPr>
           <a:xfrm>
             <a:off x="731520" y="3520440"/>
-            <a:ext cx="5440680" cy="1051560"/>
+            <a:ext cx="10698480" cy="1188720"/>
+          </a:xfrm>
+          <a:prstGeom prst="roundRect">
+            <a:avLst>
+              <a:gd name="adj" fmla="val 4000"/>
+            </a:avLst>
+          </a:prstGeom>
+          <a:solidFill>
+            <a:srgbClr val="FDF0F2"/>
+          </a:solidFill>
+          <a:ln w="12700">
+            <a:solidFill>
+              <a:srgbClr val="E51937"/>
+            </a:solidFill>
+          </a:ln>
+        </p:spPr>
+        <p:style>
+          <a:lnRef idx="1">
+            <a:schemeClr val="accent1"/>
+          </a:lnRef>
+          <a:fillRef idx="3">
+            <a:schemeClr val="accent1"/>
+          </a:fillRef>
+          <a:effectRef idx="2">
+            <a:schemeClr val="accent1"/>
+          </a:effectRef>
+          <a:fontRef idx="minor">
+            <a:schemeClr val="lt1"/>
+          </a:fontRef>
+        </p:style>
+        <p:txBody>
+          <a:bodyPr rtlCol="0" anchor="ctr"/>
+          <a:lstStyle/>
+          <a:p>
+            <a:pPr algn="ctr"/>
+          </a:p>
+        </p:txBody>
+      </p:sp>
+      <p:sp>
+        <p:nvSpPr>
+          <p:cNvPr id="26" name="Rectangle 25"/>
+          <p:cNvSpPr/>
+          <p:nvPr/>
+        </p:nvSpPr>
+        <p:spPr>
+          <a:xfrm>
+            <a:off x="731520" y="3520440"/>
+            <a:ext cx="50800" cy="1188720"/>
+          </a:xfrm>
+          <a:prstGeom prst="rect">
+            <a:avLst/>
+          </a:prstGeom>
+          <a:solidFill>
+            <a:srgbClr val="E51937"/>
+          </a:solidFill>
+          <a:ln>
+            <a:noFill/>
+          </a:ln>
+        </p:spPr>
+        <p:style>
+          <a:lnRef idx="1">
+            <a:schemeClr val="accent1"/>
+          </a:lnRef>
+          <a:fillRef idx="3">
+            <a:schemeClr val="accent1"/>
+          </a:fillRef>
+          <a:effectRef idx="2">
+            <a:schemeClr val="accent1"/>
+          </a:effectRef>
+          <a:fontRef idx="minor">
+            <a:schemeClr val="lt1"/>
+          </a:fontRef>
+        </p:style>
+        <p:txBody>
+          <a:bodyPr rtlCol="0" anchor="ctr"/>
+          <a:lstStyle/>
+          <a:p>
+            <a:pPr algn="ctr"/>
+          </a:p>
+        </p:txBody>
+      </p:sp>
+      <p:sp>
+        <p:nvSpPr>
+          <p:cNvPr id="27" name="TextBox 26"/>
+          <p:cNvSpPr txBox="1"/>
+          <p:nvPr/>
+        </p:nvSpPr>
+        <p:spPr>
+          <a:xfrm>
+            <a:off x="1005840" y="3593592"/>
+            <a:ext cx="3657600" cy="182880"/>
+          </a:xfrm>
+          <a:prstGeom prst="rect">
+            <a:avLst/>
+          </a:prstGeom>
+          <a:noFill/>
+        </p:spPr>
+        <p:txBody>
+          <a:bodyPr wrap="square">
+            <a:spAutoFit/>
+          </a:bodyPr>
+          <a:lstStyle/>
+          <a:p>
+            <a:pPr algn="l">
+              <a:defRPr sz="900" b="1" i="0">
+                <a:solidFill>
+                  <a:srgbClr val="E51937"/>
+                </a:solidFill>
+                <a:latin typeface="Calibri"/>
+              </a:defRPr>
+            </a:pPr>
+            <a:r>
+              <a:t>THE UNLOCK</a:t>
+            </a:r>
+          </a:p>
+        </p:txBody>
+      </p:sp>
+      <p:sp>
+        <p:nvSpPr>
+          <p:cNvPr id="28" name="TextBox 27"/>
+          <p:cNvSpPr txBox="1"/>
+          <p:nvPr/>
+        </p:nvSpPr>
+        <p:spPr>
+          <a:xfrm>
+            <a:off x="1005840" y="3794760"/>
+            <a:ext cx="4572000" cy="320040"/>
+          </a:xfrm>
+          <a:prstGeom prst="rect">
+            <a:avLst/>
+          </a:prstGeom>
+          <a:noFill/>
+        </p:spPr>
+        <p:txBody>
+          <a:bodyPr wrap="square">
+            <a:spAutoFit/>
+          </a:bodyPr>
+          <a:lstStyle/>
+          <a:p>
+            <a:pPr algn="l">
+              <a:defRPr sz="1600" b="1" i="0">
+                <a:solidFill>
+                  <a:srgbClr val="1C1C1E"/>
+                </a:solidFill>
+                <a:latin typeface="Calibri"/>
+              </a:defRPr>
+            </a:pPr>
+            <a:r>
+              <a:t>AXS Intelligence Platform</a:t>
+            </a:r>
+          </a:p>
+        </p:txBody>
+      </p:sp>
+      <p:sp>
+        <p:nvSpPr>
+          <p:cNvPr id="29" name="TextBox 28"/>
+          <p:cNvSpPr txBox="1"/>
+          <p:nvPr/>
+        </p:nvSpPr>
+        <p:spPr>
+          <a:xfrm>
+            <a:off x="1005840" y="4160520"/>
+            <a:ext cx="9601200" cy="457200"/>
+          </a:xfrm>
+          <a:prstGeom prst="rect">
+            <a:avLst/>
+          </a:prstGeom>
+          <a:noFill/>
+        </p:spPr>
+        <p:txBody>
+          <a:bodyPr wrap="square">
+            <a:spAutoFit/>
+          </a:bodyPr>
+          <a:lstStyle/>
+          <a:p>
+            <a:pPr algn="l">
+              <a:defRPr sz="1200" b="0" i="0">
+                <a:solidFill>
+                  <a:srgbClr val="3A3A3C"/>
+                </a:solidFill>
+                <a:latin typeface="Calibri"/>
+              </a:defRPr>
+            </a:pPr>
+            <a:r>
+              <a:t>Unified rider dashboard: power, gearing, suspension, heart rate in one view. No competitor has the product breadth to build this.</a:t>
+            </a:r>
+          </a:p>
+        </p:txBody>
+      </p:sp>
+      <p:sp>
+        <p:nvSpPr>
+          <p:cNvPr id="30" name="Rounded Rectangle 29"/>
+          <p:cNvSpPr/>
+          <p:nvPr/>
+        </p:nvSpPr>
+        <p:spPr>
+          <a:xfrm>
+            <a:off x="731520" y="4892040"/>
+            <a:ext cx="3429000" cy="1051560"/>
           </a:xfrm>
           <a:prstGeom prst="roundRect">
             <a:avLst>
@@ -22252,28 +22565,28 @@
       </p:sp>
       <p:sp>
         <p:nvSpPr>
-          <p:cNvPr id="26" name="TextBox 25"/>
-          <p:cNvSpPr txBox="1"/>
-          <p:nvPr/>
-        </p:nvSpPr>
-        <p:spPr>
-          <a:xfrm>
-            <a:off x="960120" y="3611880"/>
-            <a:ext cx="4983480" cy="274320"/>
-          </a:xfrm>
-          <a:prstGeom prst="rect">
-            <a:avLst/>
-          </a:prstGeom>
-          <a:noFill/>
-        </p:spPr>
-        <p:txBody>
-          <a:bodyPr wrap="square">
-            <a:spAutoFit/>
-          </a:bodyPr>
-          <a:lstStyle/>
-          <a:p>
-            <a:pPr algn="l">
-              <a:defRPr sz="1300" b="1" i="0">
+          <p:cNvPr id="31" name="TextBox 30"/>
+          <p:cNvSpPr txBox="1"/>
+          <p:nvPr/>
+        </p:nvSpPr>
+        <p:spPr>
+          <a:xfrm>
+            <a:off x="914400" y="4983480"/>
+            <a:ext cx="3063240" cy="274320"/>
+          </a:xfrm>
+          <a:prstGeom prst="rect">
+            <a:avLst/>
+          </a:prstGeom>
+          <a:noFill/>
+        </p:spPr>
+        <p:txBody>
+          <a:bodyPr wrap="square">
+            <a:spAutoFit/>
+          </a:bodyPr>
+          <a:lstStyle/>
+          <a:p>
+            <a:pPr algn="l">
+              <a:defRPr sz="1200" b="1" i="0">
                 <a:solidFill>
                   <a:srgbClr val="1C1C1E"/>
                 </a:solidFill>
@@ -22281,35 +22594,35 @@
               </a:defRPr>
             </a:pPr>
             <a:r>
-              <a:t>AXS Intelligence Platform</a:t>
-            </a:r>
-          </a:p>
-        </p:txBody>
-      </p:sp>
-      <p:sp>
-        <p:nvSpPr>
-          <p:cNvPr id="27" name="TextBox 26"/>
-          <p:cNvSpPr txBox="1"/>
-          <p:nvPr/>
-        </p:nvSpPr>
-        <p:spPr>
-          <a:xfrm>
-            <a:off x="960120" y="3886200"/>
-            <a:ext cx="4983480" cy="548640"/>
-          </a:xfrm>
-          <a:prstGeom prst="rect">
-            <a:avLst/>
-          </a:prstGeom>
-          <a:noFill/>
-        </p:spPr>
-        <p:txBody>
-          <a:bodyPr wrap="square">
-            <a:spAutoFit/>
-          </a:bodyPr>
-          <a:lstStyle/>
-          <a:p>
-            <a:pPr algn="l">
-              <a:defRPr sz="1100" b="0" i="0">
+              <a:t>Predictive Maintenance</a:t>
+            </a:r>
+          </a:p>
+        </p:txBody>
+      </p:sp>
+      <p:sp>
+        <p:nvSpPr>
+          <p:cNvPr id="32" name="TextBox 31"/>
+          <p:cNvSpPr txBox="1"/>
+          <p:nvPr/>
+        </p:nvSpPr>
+        <p:spPr>
+          <a:xfrm>
+            <a:off x="914400" y="5257800"/>
+            <a:ext cx="3063240" cy="548640"/>
+          </a:xfrm>
+          <a:prstGeom prst="rect">
+            <a:avLst/>
+          </a:prstGeom>
+          <a:noFill/>
+        </p:spPr>
+        <p:txBody>
+          <a:bodyPr wrap="square">
+            <a:spAutoFit/>
+          </a:bodyPr>
+          <a:lstStyle/>
+          <a:p>
+            <a:pPr algn="l">
+              <a:defRPr sz="1000" b="0" i="0">
                 <a:solidFill>
                   <a:srgbClr val="3A3A3C"/>
                 </a:solidFill>
@@ -22317,21 +22630,21 @@
               </a:defRPr>
             </a:pPr>
             <a:r>
-              <a:t>Unified rider dashboard: power, gearing, suspension, heart rate in one view. No competitor has the product breadth to build this.</a:t>
-            </a:r>
-          </a:p>
-        </p:txBody>
-      </p:sp>
-      <p:sp>
-        <p:nvSpPr>
-          <p:cNvPr id="28" name="Rounded Rectangle 27"/>
+              <a:t>Connected components predict chain and brake pad replacement before failure. Installed base becomes recurring revenue.</a:t>
+            </a:r>
+          </a:p>
+        </p:txBody>
+      </p:sp>
+      <p:sp>
+        <p:nvSpPr>
+          <p:cNvPr id="33" name="Rounded Rectangle 32"/>
           <p:cNvSpPr/>
           <p:nvPr/>
         </p:nvSpPr>
         <p:spPr>
           <a:xfrm>
-            <a:off x="6400800" y="3520440"/>
-            <a:ext cx="5440680" cy="1051560"/>
+            <a:off x="4389120" y="4892040"/>
+            <a:ext cx="3429000" cy="1051560"/>
           </a:xfrm>
           <a:prstGeom prst="roundRect">
             <a:avLst>
@@ -22371,28 +22684,28 @@
       </p:sp>
       <p:sp>
         <p:nvSpPr>
-          <p:cNvPr id="29" name="TextBox 28"/>
-          <p:cNvSpPr txBox="1"/>
-          <p:nvPr/>
-        </p:nvSpPr>
-        <p:spPr>
-          <a:xfrm>
-            <a:off x="6629400" y="3611880"/>
-            <a:ext cx="4983480" cy="274320"/>
-          </a:xfrm>
-          <a:prstGeom prst="rect">
-            <a:avLst/>
-          </a:prstGeom>
-          <a:noFill/>
-        </p:spPr>
-        <p:txBody>
-          <a:bodyPr wrap="square">
-            <a:spAutoFit/>
-          </a:bodyPr>
-          <a:lstStyle/>
-          <a:p>
-            <a:pPr algn="l">
-              <a:defRPr sz="1300" b="1" i="0">
+          <p:cNvPr id="34" name="TextBox 33"/>
+          <p:cNvSpPr txBox="1"/>
+          <p:nvPr/>
+        </p:nvSpPr>
+        <p:spPr>
+          <a:xfrm>
+            <a:off x="4572000" y="4983480"/>
+            <a:ext cx="3063240" cy="274320"/>
+          </a:xfrm>
+          <a:prstGeom prst="rect">
+            <a:avLst/>
+          </a:prstGeom>
+          <a:noFill/>
+        </p:spPr>
+        <p:txBody>
+          <a:bodyPr wrap="square">
+            <a:spAutoFit/>
+          </a:bodyPr>
+          <a:lstStyle/>
+          <a:p>
+            <a:pPr algn="l">
+              <a:defRPr sz="1200" b="1" i="0">
                 <a:solidFill>
                   <a:srgbClr val="1C1C1E"/>
                 </a:solidFill>
@@ -22400,35 +22713,35 @@
               </a:defRPr>
             </a:pPr>
             <a:r>
-              <a:t>Predictive Maintenance</a:t>
-            </a:r>
-          </a:p>
-        </p:txBody>
-      </p:sp>
-      <p:sp>
-        <p:nvSpPr>
-          <p:cNvPr id="30" name="TextBox 29"/>
-          <p:cNvSpPr txBox="1"/>
-          <p:nvPr/>
-        </p:nvSpPr>
-        <p:spPr>
-          <a:xfrm>
-            <a:off x="6629400" y="3886200"/>
-            <a:ext cx="4983480" cy="548640"/>
-          </a:xfrm>
-          <a:prstGeom prst="rect">
-            <a:avLst/>
-          </a:prstGeom>
-          <a:noFill/>
-        </p:spPr>
-        <p:txBody>
-          <a:bodyPr wrap="square">
-            <a:spAutoFit/>
-          </a:bodyPr>
-          <a:lstStyle/>
-          <a:p>
-            <a:pPr algn="l">
-              <a:defRPr sz="1100" b="0" i="0">
+              <a:t>AI-Tuned Performance</a:t>
+            </a:r>
+          </a:p>
+        </p:txBody>
+      </p:sp>
+      <p:sp>
+        <p:nvSpPr>
+          <p:cNvPr id="35" name="TextBox 34"/>
+          <p:cNvSpPr txBox="1"/>
+          <p:nvPr/>
+        </p:nvSpPr>
+        <p:spPr>
+          <a:xfrm>
+            <a:off x="4572000" y="5257800"/>
+            <a:ext cx="3063240" cy="548640"/>
+          </a:xfrm>
+          <a:prstGeom prst="rect">
+            <a:avLst/>
+          </a:prstGeom>
+          <a:noFill/>
+        </p:spPr>
+        <p:txBody>
+          <a:bodyPr wrap="square">
+            <a:spAutoFit/>
+          </a:bodyPr>
+          <a:lstStyle/>
+          <a:p>
+            <a:pPr algn="l">
+              <a:defRPr sz="1000" b="0" i="0">
                 <a:solidFill>
                   <a:srgbClr val="3A3A3C"/>
                 </a:solidFill>
@@ -22436,21 +22749,21 @@
               </a:defRPr>
             </a:pPr>
             <a:r>
-              <a:t>Connected components predict chain and brake pad replacement before failure. Installed base becomes recurring revenue.</a:t>
-            </a:r>
-          </a:p>
-        </p:txBody>
-      </p:sp>
-      <p:sp>
-        <p:nvSpPr>
-          <p:cNvPr id="31" name="Rounded Rectangle 30"/>
+              <a:t>Suspension auto-adjusts to terrain. Shifting optimizes for rider power. Products improve continuously after purchase.</a:t>
+            </a:r>
+          </a:p>
+        </p:txBody>
+      </p:sp>
+      <p:sp>
+        <p:nvSpPr>
+          <p:cNvPr id="36" name="Rounded Rectangle 35"/>
           <p:cNvSpPr/>
           <p:nvPr/>
         </p:nvSpPr>
         <p:spPr>
           <a:xfrm>
-            <a:off x="731520" y="4754880"/>
-            <a:ext cx="5440680" cy="1051560"/>
+            <a:off x="8046720" y="4892040"/>
+            <a:ext cx="3429000" cy="1051560"/>
           </a:xfrm>
           <a:prstGeom prst="roundRect">
             <a:avLst>
@@ -22490,28 +22803,28 @@
       </p:sp>
       <p:sp>
         <p:nvSpPr>
-          <p:cNvPr id="32" name="TextBox 31"/>
-          <p:cNvSpPr txBox="1"/>
-          <p:nvPr/>
-        </p:nvSpPr>
-        <p:spPr>
-          <a:xfrm>
-            <a:off x="960120" y="4846320"/>
-            <a:ext cx="4983480" cy="274320"/>
-          </a:xfrm>
-          <a:prstGeom prst="rect">
-            <a:avLst/>
-          </a:prstGeom>
-          <a:noFill/>
-        </p:spPr>
-        <p:txBody>
-          <a:bodyPr wrap="square">
-            <a:spAutoFit/>
-          </a:bodyPr>
-          <a:lstStyle/>
-          <a:p>
-            <a:pPr algn="l">
-              <a:defRPr sz="1300" b="1" i="0">
+          <p:cNvPr id="37" name="TextBox 36"/>
+          <p:cNvSpPr txBox="1"/>
+          <p:nvPr/>
+        </p:nvSpPr>
+        <p:spPr>
+          <a:xfrm>
+            <a:off x="8229600" y="4983480"/>
+            <a:ext cx="3063240" cy="274320"/>
+          </a:xfrm>
+          <a:prstGeom prst="rect">
+            <a:avLst/>
+          </a:prstGeom>
+          <a:noFill/>
+        </p:spPr>
+        <p:txBody>
+          <a:bodyPr wrap="square">
+            <a:spAutoFit/>
+          </a:bodyPr>
+          <a:lstStyle/>
+          <a:p>
+            <a:pPr algn="l">
+              <a:defRPr sz="1200" b="1" i="0">
                 <a:solidFill>
                   <a:srgbClr val="1C1C1E"/>
                 </a:solidFill>
@@ -22519,35 +22832,35 @@
               </a:defRPr>
             </a:pPr>
             <a:r>
-              <a:t>AI-Tuned Performance</a:t>
-            </a:r>
-          </a:p>
-        </p:txBody>
-      </p:sp>
-      <p:sp>
-        <p:nvSpPr>
-          <p:cNvPr id="33" name="TextBox 32"/>
-          <p:cNvSpPr txBox="1"/>
-          <p:nvPr/>
-        </p:nvSpPr>
-        <p:spPr>
-          <a:xfrm>
-            <a:off x="960120" y="5120640"/>
-            <a:ext cx="4983480" cy="548640"/>
-          </a:xfrm>
-          <a:prstGeom prst="rect">
-            <a:avLst/>
-          </a:prstGeom>
-          <a:noFill/>
-        </p:spPr>
-        <p:txBody>
-          <a:bodyPr wrap="square">
-            <a:spAutoFit/>
-          </a:bodyPr>
-          <a:lstStyle/>
-          <a:p>
-            <a:pPr algn="l">
-              <a:defRPr sz="1100" b="0" i="0">
+              <a:t>Dealer Intelligence</a:t>
+            </a:r>
+          </a:p>
+        </p:txBody>
+      </p:sp>
+      <p:sp>
+        <p:nvSpPr>
+          <p:cNvPr id="38" name="TextBox 37"/>
+          <p:cNvSpPr txBox="1"/>
+          <p:nvPr/>
+        </p:nvSpPr>
+        <p:spPr>
+          <a:xfrm>
+            <a:off x="8229600" y="5257800"/>
+            <a:ext cx="3063240" cy="548640"/>
+          </a:xfrm>
+          <a:prstGeom prst="rect">
+            <a:avLst/>
+          </a:prstGeom>
+          <a:noFill/>
+        </p:spPr>
+        <p:txBody>
+          <a:bodyPr wrap="square">
+            <a:spAutoFit/>
+          </a:bodyPr>
+          <a:lstStyle/>
+          <a:p>
+            <a:pPr algn="l">
+              <a:defRPr sz="1000" b="0" i="0">
                 <a:solidFill>
                   <a:srgbClr val="3A3A3C"/>
                 </a:solidFill>
@@ -22555,25 +22868,25 @@
               </a:defRPr>
             </a:pPr>
             <a:r>
-              <a:t>Suspension auto-adjusts to terrain. Shifting optimizes for rider power. Products improve continuously after purchase.</a:t>
-            </a:r>
-          </a:p>
-        </p:txBody>
-      </p:sp>
-      <p:sp>
-        <p:nvSpPr>
-          <p:cNvPr id="34" name="Rounded Rectangle 33"/>
+              <a:t>Telemetry tells dealers which parts approach end-of-life in their area. Proactive ordering replaces reactive.</a:t>
+            </a:r>
+          </a:p>
+        </p:txBody>
+      </p:sp>
+      <p:sp>
+        <p:nvSpPr>
+          <p:cNvPr id="39" name="Rounded Rectangle 38"/>
           <p:cNvSpPr/>
           <p:nvPr/>
         </p:nvSpPr>
         <p:spPr>
           <a:xfrm>
-            <a:off x="6400800" y="4754880"/>
-            <a:ext cx="5440680" cy="1051560"/>
+            <a:off x="731520" y="6080760"/>
+            <a:ext cx="10698480" cy="365760"/>
           </a:xfrm>
           <a:prstGeom prst="roundRect">
             <a:avLst>
-              <a:gd name="adj" fmla="val 4000"/>
+              <a:gd name="adj" fmla="val 10000"/>
             </a:avLst>
           </a:prstGeom>
           <a:solidFill>
@@ -22609,126 +22922,7 @@
       </p:sp>
       <p:sp>
         <p:nvSpPr>
-          <p:cNvPr id="35" name="TextBox 34"/>
-          <p:cNvSpPr txBox="1"/>
-          <p:nvPr/>
-        </p:nvSpPr>
-        <p:spPr>
-          <a:xfrm>
-            <a:off x="6629400" y="4846320"/>
-            <a:ext cx="4983480" cy="274320"/>
-          </a:xfrm>
-          <a:prstGeom prst="rect">
-            <a:avLst/>
-          </a:prstGeom>
-          <a:noFill/>
-        </p:spPr>
-        <p:txBody>
-          <a:bodyPr wrap="square">
-            <a:spAutoFit/>
-          </a:bodyPr>
-          <a:lstStyle/>
-          <a:p>
-            <a:pPr algn="l">
-              <a:defRPr sz="1300" b="1" i="0">
-                <a:solidFill>
-                  <a:srgbClr val="1C1C1E"/>
-                </a:solidFill>
-                <a:latin typeface="Calibri"/>
-              </a:defRPr>
-            </a:pPr>
-            <a:r>
-              <a:t>Dealer Intelligence</a:t>
-            </a:r>
-          </a:p>
-        </p:txBody>
-      </p:sp>
-      <p:sp>
-        <p:nvSpPr>
-          <p:cNvPr id="36" name="TextBox 35"/>
-          <p:cNvSpPr txBox="1"/>
-          <p:nvPr/>
-        </p:nvSpPr>
-        <p:spPr>
-          <a:xfrm>
-            <a:off x="6629400" y="5120640"/>
-            <a:ext cx="4983480" cy="548640"/>
-          </a:xfrm>
-          <a:prstGeom prst="rect">
-            <a:avLst/>
-          </a:prstGeom>
-          <a:noFill/>
-        </p:spPr>
-        <p:txBody>
-          <a:bodyPr wrap="square">
-            <a:spAutoFit/>
-          </a:bodyPr>
-          <a:lstStyle/>
-          <a:p>
-            <a:pPr algn="l">
-              <a:defRPr sz="1100" b="0" i="0">
-                <a:solidFill>
-                  <a:srgbClr val="3A3A3C"/>
-                </a:solidFill>
-                <a:latin typeface="Calibri"/>
-              </a:defRPr>
-            </a:pPr>
-            <a:r>
-              <a:t>Telemetry tells dealers which parts approach end-of-life in their area. Proactive ordering replaces reactive.</a:t>
-            </a:r>
-          </a:p>
-        </p:txBody>
-      </p:sp>
-      <p:sp>
-        <p:nvSpPr>
-          <p:cNvPr id="37" name="Rounded Rectangle 36"/>
-          <p:cNvSpPr/>
-          <p:nvPr/>
-        </p:nvSpPr>
-        <p:spPr>
-          <a:xfrm>
-            <a:off x="731520" y="6080760"/>
-            <a:ext cx="10698480" cy="365760"/>
-          </a:xfrm>
-          <a:prstGeom prst="roundRect">
-            <a:avLst>
-              <a:gd name="adj" fmla="val 10000"/>
-            </a:avLst>
-          </a:prstGeom>
-          <a:solidFill>
-            <a:srgbClr val="FFFFFF"/>
-          </a:solidFill>
-          <a:ln w="12700">
-            <a:solidFill>
-              <a:srgbClr val="E0E0DE"/>
-            </a:solidFill>
-          </a:ln>
-        </p:spPr>
-        <p:style>
-          <a:lnRef idx="1">
-            <a:schemeClr val="accent1"/>
-          </a:lnRef>
-          <a:fillRef idx="3">
-            <a:schemeClr val="accent1"/>
-          </a:fillRef>
-          <a:effectRef idx="2">
-            <a:schemeClr val="accent1"/>
-          </a:effectRef>
-          <a:fontRef idx="minor">
-            <a:schemeClr val="lt1"/>
-          </a:fontRef>
-        </p:style>
-        <p:txBody>
-          <a:bodyPr rtlCol="0" anchor="ctr"/>
-          <a:lstStyle/>
-          <a:p>
-            <a:pPr algn="ctr"/>
-          </a:p>
-        </p:txBody>
-      </p:sp>
-      <p:sp>
-        <p:nvSpPr>
-          <p:cNvPr id="38" name="Rectangle 37"/>
+          <p:cNvPr id="40" name="Rectangle 39"/>
           <p:cNvSpPr/>
           <p:nvPr/>
         </p:nvSpPr>
@@ -22771,7 +22965,7 @@
       </p:sp>
       <p:sp>
         <p:nvSpPr>
-          <p:cNvPr id="39" name="TextBox 38"/>
+          <p:cNvPr id="41" name="TextBox 40"/>
           <p:cNvSpPr txBox="1"/>
           <p:nvPr/>
         </p:nvSpPr>
@@ -22807,7 +23001,7 @@
       </p:sp>
       <p:sp>
         <p:nvSpPr>
-          <p:cNvPr id="40" name="TextBox 39"/>
+          <p:cNvPr id="42" name="TextBox 41"/>
           <p:cNvSpPr txBox="1"/>
           <p:nvPr/>
         </p:nvSpPr>
@@ -22843,7 +23037,7 @@
       </p:sp>
       <p:sp>
         <p:nvSpPr>
-          <p:cNvPr id="41" name="TextBox 40"/>
+          <p:cNvPr id="43" name="TextBox 42"/>
           <p:cNvSpPr txBox="1"/>
           <p:nvPr/>
         </p:nvSpPr>

</xml_diff>

<commit_message>
Remove emojis from intro slide, fix initiative map row spacing
Replace emoji icons with text-only cards showing brand name and
product category. Fix initiative map rows to use consistent 0.25"
gaps between all four function groups instead of uneven spacing.
</commit_message>
<xml_diff>
--- a/deliverables/SRAM_AI_Adoption_Playbook.pptx
+++ b/deliverables/SRAM_AI_Adoption_Playbook.pptx
@@ -14794,7 +14794,7 @@
         <p:spPr>
           <a:xfrm>
             <a:off x="731520" y="2011680"/>
-            <a:ext cx="1592580" cy="2560320"/>
+            <a:ext cx="1592580" cy="2194560"/>
           </a:xfrm>
           <a:prstGeom prst="roundRect">
             <a:avLst>
@@ -14840,8 +14840,8 @@
         </p:nvSpPr>
         <p:spPr>
           <a:xfrm>
-            <a:off x="731520" y="2240280"/>
-            <a:ext cx="1592580" cy="640080"/>
+            <a:off x="731520" y="2194560"/>
+            <a:ext cx="1592580" cy="228600"/>
           </a:xfrm>
           <a:prstGeom prst="rect">
             <a:avLst/>
@@ -14855,7 +14855,43 @@
           <a:lstStyle/>
           <a:p>
             <a:pPr algn="ctr">
-              <a:defRPr sz="3600" b="0" i="0">
+              <a:defRPr sz="1000" b="1" i="0">
+                <a:solidFill>
+                  <a:srgbClr val="767676"/>
+                </a:solidFill>
+                <a:latin typeface="Calibri"/>
+              </a:defRPr>
+            </a:pPr>
+            <a:r>
+              <a:t>SRAM</a:t>
+            </a:r>
+          </a:p>
+        </p:txBody>
+      </p:sp>
+      <p:sp>
+        <p:nvSpPr>
+          <p:cNvPr id="8" name="TextBox 7"/>
+          <p:cNvSpPr txBox="1"/>
+          <p:nvPr/>
+        </p:nvSpPr>
+        <p:spPr>
+          <a:xfrm>
+            <a:off x="731520" y="2514600"/>
+            <a:ext cx="1592580" cy="365760"/>
+          </a:xfrm>
+          <a:prstGeom prst="rect">
+            <a:avLst/>
+          </a:prstGeom>
+          <a:noFill/>
+        </p:spPr>
+        <p:txBody>
+          <a:bodyPr wrap="square">
+            <a:spAutoFit/>
+          </a:bodyPr>
+          <a:lstStyle/>
+          <a:p>
+            <a:pPr algn="ctr">
+              <a:defRPr sz="1800" b="1" i="0">
                 <a:solidFill>
                   <a:srgbClr val="1C1C1E"/>
                 </a:solidFill>
@@ -14863,42 +14899,6 @@
               </a:defRPr>
             </a:pPr>
             <a:r>
-              <a:t>⚙️</a:t>
-            </a:r>
-          </a:p>
-        </p:txBody>
-      </p:sp>
-      <p:sp>
-        <p:nvSpPr>
-          <p:cNvPr id="8" name="TextBox 7"/>
-          <p:cNvSpPr txBox="1"/>
-          <p:nvPr/>
-        </p:nvSpPr>
-        <p:spPr>
-          <a:xfrm>
-            <a:off x="731520" y="2926080"/>
-            <a:ext cx="1592580" cy="365760"/>
-          </a:xfrm>
-          <a:prstGeom prst="rect">
-            <a:avLst/>
-          </a:prstGeom>
-          <a:noFill/>
-        </p:spPr>
-        <p:txBody>
-          <a:bodyPr wrap="square">
-            <a:spAutoFit/>
-          </a:bodyPr>
-          <a:lstStyle/>
-          <a:p>
-            <a:pPr algn="ctr">
-              <a:defRPr sz="1600" b="1" i="0">
-                <a:solidFill>
-                  <a:srgbClr val="1C1C1E"/>
-                </a:solidFill>
-                <a:latin typeface="Calibri"/>
-              </a:defRPr>
-            </a:pPr>
-            <a:r>
               <a:t>Drivetrains</a:t>
             </a:r>
           </a:p>
@@ -14912,7 +14912,7 @@
         </p:nvSpPr>
         <p:spPr>
           <a:xfrm>
-            <a:off x="868680" y="3383280"/>
+            <a:off x="868680" y="3017520"/>
             <a:ext cx="1318260" cy="914400"/>
           </a:xfrm>
           <a:prstGeom prst="rect">
@@ -14953,7 +14953,7 @@
         <p:spPr>
           <a:xfrm>
             <a:off x="2552700" y="2011680"/>
-            <a:ext cx="1592580" cy="2560320"/>
+            <a:ext cx="1592580" cy="2194560"/>
           </a:xfrm>
           <a:prstGeom prst="roundRect">
             <a:avLst>
@@ -14999,8 +14999,8 @@
         </p:nvSpPr>
         <p:spPr>
           <a:xfrm>
-            <a:off x="2552700" y="2240280"/>
-            <a:ext cx="1592580" cy="640080"/>
+            <a:off x="2552700" y="2194560"/>
+            <a:ext cx="1592580" cy="228600"/>
           </a:xfrm>
           <a:prstGeom prst="rect">
             <a:avLst/>
@@ -15014,7 +15014,43 @@
           <a:lstStyle/>
           <a:p>
             <a:pPr algn="ctr">
-              <a:defRPr sz="3600" b="0" i="0">
+              <a:defRPr sz="1000" b="1" i="0">
+                <a:solidFill>
+                  <a:srgbClr val="767676"/>
+                </a:solidFill>
+                <a:latin typeface="Calibri"/>
+              </a:defRPr>
+            </a:pPr>
+            <a:r>
+              <a:t>SRAM</a:t>
+            </a:r>
+          </a:p>
+        </p:txBody>
+      </p:sp>
+      <p:sp>
+        <p:nvSpPr>
+          <p:cNvPr id="12" name="TextBox 11"/>
+          <p:cNvSpPr txBox="1"/>
+          <p:nvPr/>
+        </p:nvSpPr>
+        <p:spPr>
+          <a:xfrm>
+            <a:off x="2552700" y="2514600"/>
+            <a:ext cx="1592580" cy="365760"/>
+          </a:xfrm>
+          <a:prstGeom prst="rect">
+            <a:avLst/>
+          </a:prstGeom>
+          <a:noFill/>
+        </p:spPr>
+        <p:txBody>
+          <a:bodyPr wrap="square">
+            <a:spAutoFit/>
+          </a:bodyPr>
+          <a:lstStyle/>
+          <a:p>
+            <a:pPr algn="ctr">
+              <a:defRPr sz="1800" b="1" i="0">
                 <a:solidFill>
                   <a:srgbClr val="1C1C1E"/>
                 </a:solidFill>
@@ -15022,42 +15058,6 @@
               </a:defRPr>
             </a:pPr>
             <a:r>
-              <a:t>✋</a:t>
-            </a:r>
-          </a:p>
-        </p:txBody>
-      </p:sp>
-      <p:sp>
-        <p:nvSpPr>
-          <p:cNvPr id="12" name="TextBox 11"/>
-          <p:cNvSpPr txBox="1"/>
-          <p:nvPr/>
-        </p:nvSpPr>
-        <p:spPr>
-          <a:xfrm>
-            <a:off x="2552700" y="2926080"/>
-            <a:ext cx="1592580" cy="365760"/>
-          </a:xfrm>
-          <a:prstGeom prst="rect">
-            <a:avLst/>
-          </a:prstGeom>
-          <a:noFill/>
-        </p:spPr>
-        <p:txBody>
-          <a:bodyPr wrap="square">
-            <a:spAutoFit/>
-          </a:bodyPr>
-          <a:lstStyle/>
-          <a:p>
-            <a:pPr algn="ctr">
-              <a:defRPr sz="1600" b="1" i="0">
-                <a:solidFill>
-                  <a:srgbClr val="1C1C1E"/>
-                </a:solidFill>
-                <a:latin typeface="Calibri"/>
-              </a:defRPr>
-            </a:pPr>
-            <a:r>
               <a:t>Brakes</a:t>
             </a:r>
           </a:p>
@@ -15071,7 +15071,7 @@
         </p:nvSpPr>
         <p:spPr>
           <a:xfrm>
-            <a:off x="2689860" y="3383280"/>
+            <a:off x="2689860" y="3017520"/>
             <a:ext cx="1318260" cy="914400"/>
           </a:xfrm>
           <a:prstGeom prst="rect">
@@ -15112,7 +15112,7 @@
         <p:spPr>
           <a:xfrm>
             <a:off x="4373880" y="2011680"/>
-            <a:ext cx="1592580" cy="2560320"/>
+            <a:ext cx="1592580" cy="2194560"/>
           </a:xfrm>
           <a:prstGeom prst="roundRect">
             <a:avLst>
@@ -15158,8 +15158,8 @@
         </p:nvSpPr>
         <p:spPr>
           <a:xfrm>
-            <a:off x="4373880" y="2240280"/>
-            <a:ext cx="1592580" cy="640080"/>
+            <a:off x="4373880" y="2194560"/>
+            <a:ext cx="1592580" cy="228600"/>
           </a:xfrm>
           <a:prstGeom prst="rect">
             <a:avLst/>
@@ -15173,7 +15173,43 @@
           <a:lstStyle/>
           <a:p>
             <a:pPr algn="ctr">
-              <a:defRPr sz="3600" b="0" i="0">
+              <a:defRPr sz="1000" b="1" i="0">
+                <a:solidFill>
+                  <a:srgbClr val="767676"/>
+                </a:solidFill>
+                <a:latin typeface="Calibri"/>
+              </a:defRPr>
+            </a:pPr>
+            <a:r>
+              <a:t>RockShox</a:t>
+            </a:r>
+          </a:p>
+        </p:txBody>
+      </p:sp>
+      <p:sp>
+        <p:nvSpPr>
+          <p:cNvPr id="16" name="TextBox 15"/>
+          <p:cNvSpPr txBox="1"/>
+          <p:nvPr/>
+        </p:nvSpPr>
+        <p:spPr>
+          <a:xfrm>
+            <a:off x="4373880" y="2514600"/>
+            <a:ext cx="1592580" cy="365760"/>
+          </a:xfrm>
+          <a:prstGeom prst="rect">
+            <a:avLst/>
+          </a:prstGeom>
+          <a:noFill/>
+        </p:spPr>
+        <p:txBody>
+          <a:bodyPr wrap="square">
+            <a:spAutoFit/>
+          </a:bodyPr>
+          <a:lstStyle/>
+          <a:p>
+            <a:pPr algn="ctr">
+              <a:defRPr sz="1800" b="1" i="0">
                 <a:solidFill>
                   <a:srgbClr val="1C1C1E"/>
                 </a:solidFill>
@@ -15181,42 +15217,6 @@
               </a:defRPr>
             </a:pPr>
             <a:r>
-              <a:t>🏋</a:t>
-            </a:r>
-          </a:p>
-        </p:txBody>
-      </p:sp>
-      <p:sp>
-        <p:nvSpPr>
-          <p:cNvPr id="16" name="TextBox 15"/>
-          <p:cNvSpPr txBox="1"/>
-          <p:nvPr/>
-        </p:nvSpPr>
-        <p:spPr>
-          <a:xfrm>
-            <a:off x="4373880" y="2926080"/>
-            <a:ext cx="1592580" cy="365760"/>
-          </a:xfrm>
-          <a:prstGeom prst="rect">
-            <a:avLst/>
-          </a:prstGeom>
-          <a:noFill/>
-        </p:spPr>
-        <p:txBody>
-          <a:bodyPr wrap="square">
-            <a:spAutoFit/>
-          </a:bodyPr>
-          <a:lstStyle/>
-          <a:p>
-            <a:pPr algn="ctr">
-              <a:defRPr sz="1600" b="1" i="0">
-                <a:solidFill>
-                  <a:srgbClr val="1C1C1E"/>
-                </a:solidFill>
-                <a:latin typeface="Calibri"/>
-              </a:defRPr>
-            </a:pPr>
-            <a:r>
               <a:t>Suspension</a:t>
             </a:r>
           </a:p>
@@ -15230,7 +15230,7 @@
         </p:nvSpPr>
         <p:spPr>
           <a:xfrm>
-            <a:off x="4511040" y="3383280"/>
+            <a:off x="4511040" y="3017520"/>
             <a:ext cx="1318260" cy="914400"/>
           </a:xfrm>
           <a:prstGeom prst="rect">
@@ -15253,11 +15253,11 @@
               </a:defRPr>
             </a:pPr>
             <a:r>
-              <a:t>RockShox forks that</a:t>
+              <a:t>Forks that absorb</a:t>
             </a:r>
             <a:br/>
             <a:r>
-              <a:t>absorb bumps on trails</a:t>
+              <a:t>bumps on trails</a:t>
             </a:r>
           </a:p>
         </p:txBody>
@@ -15271,7 +15271,7 @@
         <p:spPr>
           <a:xfrm>
             <a:off x="6195060" y="2011680"/>
-            <a:ext cx="1592580" cy="2560320"/>
+            <a:ext cx="1592580" cy="2194560"/>
           </a:xfrm>
           <a:prstGeom prst="roundRect">
             <a:avLst>
@@ -15317,8 +15317,8 @@
         </p:nvSpPr>
         <p:spPr>
           <a:xfrm>
-            <a:off x="6195060" y="2240280"/>
-            <a:ext cx="1592580" cy="640080"/>
+            <a:off x="6195060" y="2194560"/>
+            <a:ext cx="1592580" cy="228600"/>
           </a:xfrm>
           <a:prstGeom prst="rect">
             <a:avLst/>
@@ -15332,7 +15332,43 @@
           <a:lstStyle/>
           <a:p>
             <a:pPr algn="ctr">
-              <a:defRPr sz="3600" b="0" i="0">
+              <a:defRPr sz="1000" b="1" i="0">
+                <a:solidFill>
+                  <a:srgbClr val="767676"/>
+                </a:solidFill>
+                <a:latin typeface="Calibri"/>
+              </a:defRPr>
+            </a:pPr>
+            <a:r>
+              <a:t>Zipp</a:t>
+            </a:r>
+          </a:p>
+        </p:txBody>
+      </p:sp>
+      <p:sp>
+        <p:nvSpPr>
+          <p:cNvPr id="20" name="TextBox 19"/>
+          <p:cNvSpPr txBox="1"/>
+          <p:nvPr/>
+        </p:nvSpPr>
+        <p:spPr>
+          <a:xfrm>
+            <a:off x="6195060" y="2514600"/>
+            <a:ext cx="1592580" cy="365760"/>
+          </a:xfrm>
+          <a:prstGeom prst="rect">
+            <a:avLst/>
+          </a:prstGeom>
+          <a:noFill/>
+        </p:spPr>
+        <p:txBody>
+          <a:bodyPr wrap="square">
+            <a:spAutoFit/>
+          </a:bodyPr>
+          <a:lstStyle/>
+          <a:p>
+            <a:pPr algn="ctr">
+              <a:defRPr sz="1800" b="1" i="0">
                 <a:solidFill>
                   <a:srgbClr val="1C1C1E"/>
                 </a:solidFill>
@@ -15340,42 +15376,6 @@
               </a:defRPr>
             </a:pPr>
             <a:r>
-              <a:t>💨</a:t>
-            </a:r>
-          </a:p>
-        </p:txBody>
-      </p:sp>
-      <p:sp>
-        <p:nvSpPr>
-          <p:cNvPr id="20" name="TextBox 19"/>
-          <p:cNvSpPr txBox="1"/>
-          <p:nvPr/>
-        </p:nvSpPr>
-        <p:spPr>
-          <a:xfrm>
-            <a:off x="6195060" y="2926080"/>
-            <a:ext cx="1592580" cy="365760"/>
-          </a:xfrm>
-          <a:prstGeom prst="rect">
-            <a:avLst/>
-          </a:prstGeom>
-          <a:noFill/>
-        </p:spPr>
-        <p:txBody>
-          <a:bodyPr wrap="square">
-            <a:spAutoFit/>
-          </a:bodyPr>
-          <a:lstStyle/>
-          <a:p>
-            <a:pPr algn="ctr">
-              <a:defRPr sz="1600" b="1" i="0">
-                <a:solidFill>
-                  <a:srgbClr val="1C1C1E"/>
-                </a:solidFill>
-                <a:latin typeface="Calibri"/>
-              </a:defRPr>
-            </a:pPr>
-            <a:r>
               <a:t>Wheels</a:t>
             </a:r>
           </a:p>
@@ -15389,7 +15389,7 @@
         </p:nvSpPr>
         <p:spPr>
           <a:xfrm>
-            <a:off x="6332220" y="3383280"/>
+            <a:off x="6332220" y="3017520"/>
             <a:ext cx="1318260" cy="914400"/>
           </a:xfrm>
           <a:prstGeom prst="rect">
@@ -15412,7 +15412,7 @@
               </a:defRPr>
             </a:pPr>
             <a:r>
-              <a:t>Zipp aero wheels built</a:t>
+              <a:t>Aero wheels built</a:t>
             </a:r>
             <a:br/>
             <a:r>
@@ -15430,7 +15430,7 @@
         <p:spPr>
           <a:xfrm>
             <a:off x="8016240" y="2011680"/>
-            <a:ext cx="1592580" cy="2560320"/>
+            <a:ext cx="1592580" cy="2194560"/>
           </a:xfrm>
           <a:prstGeom prst="roundRect">
             <a:avLst>
@@ -15476,8 +15476,8 @@
         </p:nvSpPr>
         <p:spPr>
           <a:xfrm>
-            <a:off x="8016240" y="2240280"/>
-            <a:ext cx="1592580" cy="640080"/>
+            <a:off x="8016240" y="2194560"/>
+            <a:ext cx="1592580" cy="228600"/>
           </a:xfrm>
           <a:prstGeom prst="rect">
             <a:avLst/>
@@ -15491,7 +15491,43 @@
           <a:lstStyle/>
           <a:p>
             <a:pPr algn="ctr">
-              <a:defRPr sz="3600" b="0" i="0">
+              <a:defRPr sz="1000" b="1" i="0">
+                <a:solidFill>
+                  <a:srgbClr val="767676"/>
+                </a:solidFill>
+                <a:latin typeface="Calibri"/>
+              </a:defRPr>
+            </a:pPr>
+            <a:r>
+              <a:t>Quarq</a:t>
+            </a:r>
+          </a:p>
+        </p:txBody>
+      </p:sp>
+      <p:sp>
+        <p:nvSpPr>
+          <p:cNvPr id="24" name="TextBox 23"/>
+          <p:cNvSpPr txBox="1"/>
+          <p:nvPr/>
+        </p:nvSpPr>
+        <p:spPr>
+          <a:xfrm>
+            <a:off x="8016240" y="2514600"/>
+            <a:ext cx="1592580" cy="365760"/>
+          </a:xfrm>
+          <a:prstGeom prst="rect">
+            <a:avLst/>
+          </a:prstGeom>
+          <a:noFill/>
+        </p:spPr>
+        <p:txBody>
+          <a:bodyPr wrap="square">
+            <a:spAutoFit/>
+          </a:bodyPr>
+          <a:lstStyle/>
+          <a:p>
+            <a:pPr algn="ctr">
+              <a:defRPr sz="1800" b="1" i="0">
                 <a:solidFill>
                   <a:srgbClr val="1C1C1E"/>
                 </a:solidFill>
@@ -15499,42 +15535,6 @@
               </a:defRPr>
             </a:pPr>
             <a:r>
-              <a:t>📊</a:t>
-            </a:r>
-          </a:p>
-        </p:txBody>
-      </p:sp>
-      <p:sp>
-        <p:nvSpPr>
-          <p:cNvPr id="24" name="TextBox 23"/>
-          <p:cNvSpPr txBox="1"/>
-          <p:nvPr/>
-        </p:nvSpPr>
-        <p:spPr>
-          <a:xfrm>
-            <a:off x="8016240" y="2926080"/>
-            <a:ext cx="1592580" cy="365760"/>
-          </a:xfrm>
-          <a:prstGeom prst="rect">
-            <a:avLst/>
-          </a:prstGeom>
-          <a:noFill/>
-        </p:spPr>
-        <p:txBody>
-          <a:bodyPr wrap="square">
-            <a:spAutoFit/>
-          </a:bodyPr>
-          <a:lstStyle/>
-          <a:p>
-            <a:pPr algn="ctr">
-              <a:defRPr sz="1600" b="1" i="0">
-                <a:solidFill>
-                  <a:srgbClr val="1C1C1E"/>
-                </a:solidFill>
-                <a:latin typeface="Calibri"/>
-              </a:defRPr>
-            </a:pPr>
-            <a:r>
               <a:t>Sensors</a:t>
             </a:r>
           </a:p>
@@ -15548,7 +15548,7 @@
         </p:nvSpPr>
         <p:spPr>
           <a:xfrm>
-            <a:off x="8153400" y="3383280"/>
+            <a:off x="8153400" y="3017520"/>
             <a:ext cx="1318260" cy="914400"/>
           </a:xfrm>
           <a:prstGeom prst="rect">
@@ -15571,11 +15571,11 @@
               </a:defRPr>
             </a:pPr>
             <a:r>
-              <a:t>Quarq power meters</a:t>
+              <a:t>Power meters that</a:t>
             </a:r>
             <a:br/>
             <a:r>
-              <a:t>that measure performance</a:t>
+              <a:t>measure performance</a:t>
             </a:r>
           </a:p>
         </p:txBody>
@@ -15589,7 +15589,7 @@
         <p:spPr>
           <a:xfrm>
             <a:off x="9837420" y="2011680"/>
-            <a:ext cx="1592580" cy="2560320"/>
+            <a:ext cx="1592580" cy="2194560"/>
           </a:xfrm>
           <a:prstGeom prst="roundRect">
             <a:avLst>
@@ -15635,8 +15635,8 @@
         </p:nvSpPr>
         <p:spPr>
           <a:xfrm>
-            <a:off x="9837420" y="2240280"/>
-            <a:ext cx="1592580" cy="640080"/>
+            <a:off x="9837420" y="2194560"/>
+            <a:ext cx="1592580" cy="228600"/>
           </a:xfrm>
           <a:prstGeom prst="rect">
             <a:avLst/>
@@ -15650,7 +15650,43 @@
           <a:lstStyle/>
           <a:p>
             <a:pPr algn="ctr">
-              <a:defRPr sz="3600" b="0" i="0">
+              <a:defRPr sz="1000" b="1" i="0">
+                <a:solidFill>
+                  <a:srgbClr val="767676"/>
+                </a:solidFill>
+                <a:latin typeface="Calibri"/>
+              </a:defRPr>
+            </a:pPr>
+            <a:r>
+              <a:t>AXS</a:t>
+            </a:r>
+          </a:p>
+        </p:txBody>
+      </p:sp>
+      <p:sp>
+        <p:nvSpPr>
+          <p:cNvPr id="28" name="TextBox 27"/>
+          <p:cNvSpPr txBox="1"/>
+          <p:nvPr/>
+        </p:nvSpPr>
+        <p:spPr>
+          <a:xfrm>
+            <a:off x="9837420" y="2514600"/>
+            <a:ext cx="1592580" cy="365760"/>
+          </a:xfrm>
+          <a:prstGeom prst="rect">
+            <a:avLst/>
+          </a:prstGeom>
+          <a:noFill/>
+        </p:spPr>
+        <p:txBody>
+          <a:bodyPr wrap="square">
+            <a:spAutoFit/>
+          </a:bodyPr>
+          <a:lstStyle/>
+          <a:p>
+            <a:pPr algn="ctr">
+              <a:defRPr sz="1800" b="1" i="0">
                 <a:solidFill>
                   <a:srgbClr val="1C1C1E"/>
                 </a:solidFill>
@@ -15658,42 +15694,6 @@
               </a:defRPr>
             </a:pPr>
             <a:r>
-              <a:t>📱</a:t>
-            </a:r>
-          </a:p>
-        </p:txBody>
-      </p:sp>
-      <p:sp>
-        <p:nvSpPr>
-          <p:cNvPr id="28" name="TextBox 27"/>
-          <p:cNvSpPr txBox="1"/>
-          <p:nvPr/>
-        </p:nvSpPr>
-        <p:spPr>
-          <a:xfrm>
-            <a:off x="9837420" y="2926080"/>
-            <a:ext cx="1592580" cy="365760"/>
-          </a:xfrm>
-          <a:prstGeom prst="rect">
-            <a:avLst/>
-          </a:prstGeom>
-          <a:noFill/>
-        </p:spPr>
-        <p:txBody>
-          <a:bodyPr wrap="square">
-            <a:spAutoFit/>
-          </a:bodyPr>
-          <a:lstStyle/>
-          <a:p>
-            <a:pPr algn="ctr">
-              <a:defRPr sz="1600" b="1" i="0">
-                <a:solidFill>
-                  <a:srgbClr val="1C1C1E"/>
-                </a:solidFill>
-                <a:latin typeface="Calibri"/>
-              </a:defRPr>
-            </a:pPr>
-            <a:r>
               <a:t>App</a:t>
             </a:r>
           </a:p>
@@ -15707,7 +15707,7 @@
         </p:nvSpPr>
         <p:spPr>
           <a:xfrm>
-            <a:off x="9974580" y="3383280"/>
+            <a:off x="9974580" y="3017520"/>
             <a:ext cx="1318260" cy="914400"/>
           </a:xfrm>
           <a:prstGeom prst="rect">
@@ -15730,11 +15730,11 @@
               </a:defRPr>
             </a:pPr>
             <a:r>
-              <a:t>AXS app that connects</a:t>
+              <a:t>Connects all components</a:t>
             </a:r>
             <a:br/>
             <a:r>
-              <a:t>all components digitally</a:t>
+              <a:t>into one digital ecosystem</a:t>
             </a:r>
           </a:p>
         </p:txBody>
@@ -15747,7 +15747,7 @@
         </p:nvSpPr>
         <p:spPr>
           <a:xfrm>
-            <a:off x="731520" y="4937760"/>
+            <a:off x="731520" y="4572000"/>
             <a:ext cx="10698480" cy="457200"/>
           </a:xfrm>
           <a:prstGeom prst="rect">
@@ -27133,7 +27133,7 @@
         </p:nvSpPr>
         <p:spPr>
           <a:xfrm>
-            <a:off x="731520" y="3154680"/>
+            <a:off x="731520" y="2971800"/>
             <a:ext cx="50800" cy="822960"/>
           </a:xfrm>
           <a:prstGeom prst="rect">
@@ -27176,7 +27176,7 @@
         </p:nvSpPr>
         <p:spPr>
           <a:xfrm>
-            <a:off x="868680" y="3383280"/>
+            <a:off x="868680" y="3200400"/>
             <a:ext cx="1234440" cy="365760"/>
           </a:xfrm>
           <a:prstGeom prst="rect">
@@ -27212,7 +27212,7 @@
         </p:nvSpPr>
         <p:spPr>
           <a:xfrm>
-            <a:off x="2194560" y="3154680"/>
+            <a:off x="2194560" y="2971800"/>
             <a:ext cx="2926080" cy="822960"/>
           </a:xfrm>
           <a:prstGeom prst="roundRect">
@@ -27259,7 +27259,7 @@
         </p:nvSpPr>
         <p:spPr>
           <a:xfrm>
-            <a:off x="2377440" y="3383280"/>
+            <a:off x="2377440" y="3200400"/>
             <a:ext cx="2560320" cy="274320"/>
           </a:xfrm>
           <a:prstGeom prst="rect">
@@ -27295,7 +27295,7 @@
         </p:nvSpPr>
         <p:spPr>
           <a:xfrm>
-            <a:off x="2377440" y="3657600"/>
+            <a:off x="2377440" y="3474720"/>
             <a:ext cx="2560320" cy="274320"/>
           </a:xfrm>
           <a:prstGeom prst="rect">
@@ -27331,7 +27331,7 @@
         </p:nvSpPr>
         <p:spPr>
           <a:xfrm>
-            <a:off x="5257800" y="3154680"/>
+            <a:off x="5257800" y="2971800"/>
             <a:ext cx="2926080" cy="822960"/>
           </a:xfrm>
           <a:prstGeom prst="roundRect">
@@ -27378,7 +27378,7 @@
         </p:nvSpPr>
         <p:spPr>
           <a:xfrm>
-            <a:off x="5440680" y="3383280"/>
+            <a:off x="5440680" y="3200400"/>
             <a:ext cx="2560320" cy="274320"/>
           </a:xfrm>
           <a:prstGeom prst="rect">
@@ -27414,7 +27414,7 @@
         </p:nvSpPr>
         <p:spPr>
           <a:xfrm>
-            <a:off x="5440680" y="3657600"/>
+            <a:off x="5440680" y="3474720"/>
             <a:ext cx="2560320" cy="274320"/>
           </a:xfrm>
           <a:prstGeom prst="rect">
@@ -27450,7 +27450,7 @@
         </p:nvSpPr>
         <p:spPr>
           <a:xfrm>
-            <a:off x="8321040" y="3154680"/>
+            <a:off x="8321040" y="2971800"/>
             <a:ext cx="2926080" cy="822960"/>
           </a:xfrm>
           <a:prstGeom prst="roundRect">
@@ -27497,7 +27497,7 @@
         </p:nvSpPr>
         <p:spPr>
           <a:xfrm>
-            <a:off x="8503920" y="3383280"/>
+            <a:off x="8503920" y="3200400"/>
             <a:ext cx="2560320" cy="274320"/>
           </a:xfrm>
           <a:prstGeom prst="rect">
@@ -27533,7 +27533,7 @@
         </p:nvSpPr>
         <p:spPr>
           <a:xfrm>
-            <a:off x="8503920" y="3657600"/>
+            <a:off x="8503920" y="3474720"/>
             <a:ext cx="2560320" cy="274320"/>
           </a:xfrm>
           <a:prstGeom prst="rect">
@@ -28448,7 +28448,7 @@
         </p:nvSpPr>
         <p:spPr>
           <a:xfrm>
-            <a:off x="731520" y="3154680"/>
+            <a:off x="731520" y="2971800"/>
             <a:ext cx="50800" cy="822960"/>
           </a:xfrm>
           <a:prstGeom prst="rect">
@@ -28491,7 +28491,7 @@
         </p:nvSpPr>
         <p:spPr>
           <a:xfrm>
-            <a:off x="868680" y="3383280"/>
+            <a:off x="868680" y="3200400"/>
             <a:ext cx="1234440" cy="365760"/>
           </a:xfrm>
           <a:prstGeom prst="rect">
@@ -28527,7 +28527,7 @@
         </p:nvSpPr>
         <p:spPr>
           <a:xfrm>
-            <a:off x="2194560" y="3154680"/>
+            <a:off x="2194560" y="2971800"/>
             <a:ext cx="2926080" cy="822960"/>
           </a:xfrm>
           <a:prstGeom prst="roundRect">
@@ -28574,7 +28574,7 @@
         </p:nvSpPr>
         <p:spPr>
           <a:xfrm>
-            <a:off x="2377440" y="3383280"/>
+            <a:off x="2377440" y="3200400"/>
             <a:ext cx="2560320" cy="274320"/>
           </a:xfrm>
           <a:prstGeom prst="rect">
@@ -28610,7 +28610,7 @@
         </p:nvSpPr>
         <p:spPr>
           <a:xfrm>
-            <a:off x="2377440" y="3657600"/>
+            <a:off x="2377440" y="3474720"/>
             <a:ext cx="2560320" cy="274320"/>
           </a:xfrm>
           <a:prstGeom prst="rect">
@@ -28646,7 +28646,7 @@
         </p:nvSpPr>
         <p:spPr>
           <a:xfrm>
-            <a:off x="5257800" y="3154680"/>
+            <a:off x="5257800" y="2971800"/>
             <a:ext cx="2926080" cy="822960"/>
           </a:xfrm>
           <a:prstGeom prst="roundRect">
@@ -28693,7 +28693,7 @@
         </p:nvSpPr>
         <p:spPr>
           <a:xfrm>
-            <a:off x="5440680" y="3383280"/>
+            <a:off x="5440680" y="3200400"/>
             <a:ext cx="2560320" cy="274320"/>
           </a:xfrm>
           <a:prstGeom prst="rect">
@@ -28729,7 +28729,7 @@
         </p:nvSpPr>
         <p:spPr>
           <a:xfrm>
-            <a:off x="5440680" y="3657600"/>
+            <a:off x="5440680" y="3474720"/>
             <a:ext cx="2560320" cy="274320"/>
           </a:xfrm>
           <a:prstGeom prst="rect">
@@ -28765,7 +28765,7 @@
         </p:nvSpPr>
         <p:spPr>
           <a:xfrm>
-            <a:off x="8321040" y="3154680"/>
+            <a:off x="8321040" y="2971800"/>
             <a:ext cx="2926080" cy="822960"/>
           </a:xfrm>
           <a:prstGeom prst="roundRect">
@@ -28812,7 +28812,7 @@
         </p:nvSpPr>
         <p:spPr>
           <a:xfrm>
-            <a:off x="8503920" y="3383280"/>
+            <a:off x="8503920" y="3200400"/>
             <a:ext cx="2560320" cy="274320"/>
           </a:xfrm>
           <a:prstGeom prst="rect">
@@ -28848,7 +28848,7 @@
         </p:nvSpPr>
         <p:spPr>
           <a:xfrm>
-            <a:off x="8503920" y="3657600"/>
+            <a:off x="8503920" y="3474720"/>
             <a:ext cx="2560320" cy="274320"/>
           </a:xfrm>
           <a:prstGeom prst="rect">
@@ -28884,7 +28884,7 @@
         </p:nvSpPr>
         <p:spPr>
           <a:xfrm>
-            <a:off x="731520" y="4069080"/>
+            <a:off x="731520" y="4023360"/>
             <a:ext cx="50800" cy="822960"/>
           </a:xfrm>
           <a:prstGeom prst="rect">
@@ -28927,7 +28927,7 @@
         </p:nvSpPr>
         <p:spPr>
           <a:xfrm>
-            <a:off x="868680" y="4297680"/>
+            <a:off x="868680" y="4251960"/>
             <a:ext cx="1234440" cy="365760"/>
           </a:xfrm>
           <a:prstGeom prst="rect">
@@ -28963,7 +28963,7 @@
         </p:nvSpPr>
         <p:spPr>
           <a:xfrm>
-            <a:off x="2194560" y="4069080"/>
+            <a:off x="2194560" y="4023360"/>
             <a:ext cx="2926080" cy="822960"/>
           </a:xfrm>
           <a:prstGeom prst="roundRect">
@@ -29010,7 +29010,7 @@
         </p:nvSpPr>
         <p:spPr>
           <a:xfrm>
-            <a:off x="2377440" y="4297680"/>
+            <a:off x="2377440" y="4251960"/>
             <a:ext cx="2560320" cy="274320"/>
           </a:xfrm>
           <a:prstGeom prst="rect">
@@ -29046,7 +29046,7 @@
         </p:nvSpPr>
         <p:spPr>
           <a:xfrm>
-            <a:off x="2377440" y="4572000"/>
+            <a:off x="2377440" y="4526280"/>
             <a:ext cx="2560320" cy="274320"/>
           </a:xfrm>
           <a:prstGeom prst="rect">
@@ -29082,7 +29082,7 @@
         </p:nvSpPr>
         <p:spPr>
           <a:xfrm>
-            <a:off x="5257800" y="4069080"/>
+            <a:off x="5257800" y="4023360"/>
             <a:ext cx="2926080" cy="822960"/>
           </a:xfrm>
           <a:prstGeom prst="roundRect">
@@ -29129,7 +29129,7 @@
         </p:nvSpPr>
         <p:spPr>
           <a:xfrm>
-            <a:off x="5440680" y="4297680"/>
+            <a:off x="5440680" y="4251960"/>
             <a:ext cx="2560320" cy="274320"/>
           </a:xfrm>
           <a:prstGeom prst="rect">
@@ -29165,7 +29165,7 @@
         </p:nvSpPr>
         <p:spPr>
           <a:xfrm>
-            <a:off x="5440680" y="4572000"/>
+            <a:off x="5440680" y="4526280"/>
             <a:ext cx="2560320" cy="274320"/>
           </a:xfrm>
           <a:prstGeom prst="rect">
@@ -29201,7 +29201,7 @@
         </p:nvSpPr>
         <p:spPr>
           <a:xfrm>
-            <a:off x="8321040" y="4069080"/>
+            <a:off x="8321040" y="4023360"/>
             <a:ext cx="2926080" cy="822960"/>
           </a:xfrm>
           <a:prstGeom prst="roundRect">
@@ -29248,7 +29248,7 @@
         </p:nvSpPr>
         <p:spPr>
           <a:xfrm>
-            <a:off x="8503920" y="4297680"/>
+            <a:off x="8503920" y="4251960"/>
             <a:ext cx="2560320" cy="274320"/>
           </a:xfrm>
           <a:prstGeom prst="rect">
@@ -29284,7 +29284,7 @@
         </p:nvSpPr>
         <p:spPr>
           <a:xfrm>
-            <a:off x="8503920" y="4572000"/>
+            <a:off x="8503920" y="4526280"/>
             <a:ext cx="2560320" cy="274320"/>
           </a:xfrm>
           <a:prstGeom prst="rect">
@@ -30199,7 +30199,7 @@
         </p:nvSpPr>
         <p:spPr>
           <a:xfrm>
-            <a:off x="731520" y="3154680"/>
+            <a:off x="731520" y="2971800"/>
             <a:ext cx="50800" cy="822960"/>
           </a:xfrm>
           <a:prstGeom prst="rect">
@@ -30242,7 +30242,7 @@
         </p:nvSpPr>
         <p:spPr>
           <a:xfrm>
-            <a:off x="868680" y="3383280"/>
+            <a:off x="868680" y="3200400"/>
             <a:ext cx="1234440" cy="365760"/>
           </a:xfrm>
           <a:prstGeom prst="rect">
@@ -30278,7 +30278,7 @@
         </p:nvSpPr>
         <p:spPr>
           <a:xfrm>
-            <a:off x="2194560" y="3154680"/>
+            <a:off x="2194560" y="2971800"/>
             <a:ext cx="2926080" cy="822960"/>
           </a:xfrm>
           <a:prstGeom prst="roundRect">
@@ -30325,7 +30325,7 @@
         </p:nvSpPr>
         <p:spPr>
           <a:xfrm>
-            <a:off x="2377440" y="3383280"/>
+            <a:off x="2377440" y="3200400"/>
             <a:ext cx="2560320" cy="274320"/>
           </a:xfrm>
           <a:prstGeom prst="rect">
@@ -30361,7 +30361,7 @@
         </p:nvSpPr>
         <p:spPr>
           <a:xfrm>
-            <a:off x="2377440" y="3657600"/>
+            <a:off x="2377440" y="3474720"/>
             <a:ext cx="2560320" cy="274320"/>
           </a:xfrm>
           <a:prstGeom prst="rect">
@@ -30397,7 +30397,7 @@
         </p:nvSpPr>
         <p:spPr>
           <a:xfrm>
-            <a:off x="5257800" y="3154680"/>
+            <a:off x="5257800" y="2971800"/>
             <a:ext cx="2926080" cy="822960"/>
           </a:xfrm>
           <a:prstGeom prst="roundRect">
@@ -30444,7 +30444,7 @@
         </p:nvSpPr>
         <p:spPr>
           <a:xfrm>
-            <a:off x="5440680" y="3383280"/>
+            <a:off x="5440680" y="3200400"/>
             <a:ext cx="2560320" cy="274320"/>
           </a:xfrm>
           <a:prstGeom prst="rect">
@@ -30480,7 +30480,7 @@
         </p:nvSpPr>
         <p:spPr>
           <a:xfrm>
-            <a:off x="5440680" y="3657600"/>
+            <a:off x="5440680" y="3474720"/>
             <a:ext cx="2560320" cy="274320"/>
           </a:xfrm>
           <a:prstGeom prst="rect">
@@ -30516,7 +30516,7 @@
         </p:nvSpPr>
         <p:spPr>
           <a:xfrm>
-            <a:off x="8321040" y="3154680"/>
+            <a:off x="8321040" y="2971800"/>
             <a:ext cx="2926080" cy="822960"/>
           </a:xfrm>
           <a:prstGeom prst="roundRect">
@@ -30563,7 +30563,7 @@
         </p:nvSpPr>
         <p:spPr>
           <a:xfrm>
-            <a:off x="8503920" y="3383280"/>
+            <a:off x="8503920" y="3200400"/>
             <a:ext cx="2560320" cy="274320"/>
           </a:xfrm>
           <a:prstGeom prst="rect">
@@ -30599,7 +30599,7 @@
         </p:nvSpPr>
         <p:spPr>
           <a:xfrm>
-            <a:off x="8503920" y="3657600"/>
+            <a:off x="8503920" y="3474720"/>
             <a:ext cx="2560320" cy="274320"/>
           </a:xfrm>
           <a:prstGeom prst="rect">
@@ -30635,7 +30635,7 @@
         </p:nvSpPr>
         <p:spPr>
           <a:xfrm>
-            <a:off x="731520" y="4069080"/>
+            <a:off x="731520" y="4023360"/>
             <a:ext cx="50800" cy="822960"/>
           </a:xfrm>
           <a:prstGeom prst="rect">
@@ -30678,7 +30678,7 @@
         </p:nvSpPr>
         <p:spPr>
           <a:xfrm>
-            <a:off x="868680" y="4297680"/>
+            <a:off x="868680" y="4251960"/>
             <a:ext cx="1234440" cy="365760"/>
           </a:xfrm>
           <a:prstGeom prst="rect">
@@ -30714,7 +30714,7 @@
         </p:nvSpPr>
         <p:spPr>
           <a:xfrm>
-            <a:off x="2194560" y="4069080"/>
+            <a:off x="2194560" y="4023360"/>
             <a:ext cx="2926080" cy="822960"/>
           </a:xfrm>
           <a:prstGeom prst="roundRect">
@@ -30761,7 +30761,7 @@
         </p:nvSpPr>
         <p:spPr>
           <a:xfrm>
-            <a:off x="2377440" y="4297680"/>
+            <a:off x="2377440" y="4251960"/>
             <a:ext cx="2560320" cy="274320"/>
           </a:xfrm>
           <a:prstGeom prst="rect">
@@ -30797,7 +30797,7 @@
         </p:nvSpPr>
         <p:spPr>
           <a:xfrm>
-            <a:off x="2377440" y="4572000"/>
+            <a:off x="2377440" y="4526280"/>
             <a:ext cx="2560320" cy="274320"/>
           </a:xfrm>
           <a:prstGeom prst="rect">
@@ -30833,7 +30833,7 @@
         </p:nvSpPr>
         <p:spPr>
           <a:xfrm>
-            <a:off x="5257800" y="4069080"/>
+            <a:off x="5257800" y="4023360"/>
             <a:ext cx="2926080" cy="822960"/>
           </a:xfrm>
           <a:prstGeom prst="roundRect">
@@ -30880,7 +30880,7 @@
         </p:nvSpPr>
         <p:spPr>
           <a:xfrm>
-            <a:off x="5440680" y="4297680"/>
+            <a:off x="5440680" y="4251960"/>
             <a:ext cx="2560320" cy="274320"/>
           </a:xfrm>
           <a:prstGeom prst="rect">
@@ -30916,7 +30916,7 @@
         </p:nvSpPr>
         <p:spPr>
           <a:xfrm>
-            <a:off x="5440680" y="4572000"/>
+            <a:off x="5440680" y="4526280"/>
             <a:ext cx="2560320" cy="274320"/>
           </a:xfrm>
           <a:prstGeom prst="rect">
@@ -30952,7 +30952,7 @@
         </p:nvSpPr>
         <p:spPr>
           <a:xfrm>
-            <a:off x="8321040" y="4069080"/>
+            <a:off x="8321040" y="4023360"/>
             <a:ext cx="2926080" cy="822960"/>
           </a:xfrm>
           <a:prstGeom prst="roundRect">
@@ -30999,7 +30999,7 @@
         </p:nvSpPr>
         <p:spPr>
           <a:xfrm>
-            <a:off x="8503920" y="4297680"/>
+            <a:off x="8503920" y="4251960"/>
             <a:ext cx="2560320" cy="274320"/>
           </a:xfrm>
           <a:prstGeom prst="rect">
@@ -31035,7 +31035,7 @@
         </p:nvSpPr>
         <p:spPr>
           <a:xfrm>
-            <a:off x="8503920" y="4572000"/>
+            <a:off x="8503920" y="4526280"/>
             <a:ext cx="2560320" cy="274320"/>
           </a:xfrm>
           <a:prstGeom prst="rect">
@@ -31071,7 +31071,7 @@
         </p:nvSpPr>
         <p:spPr>
           <a:xfrm>
-            <a:off x="731520" y="4983480"/>
+            <a:off x="731520" y="5074919"/>
             <a:ext cx="50800" cy="822960"/>
           </a:xfrm>
           <a:prstGeom prst="rect">
@@ -31114,7 +31114,7 @@
         </p:nvSpPr>
         <p:spPr>
           <a:xfrm>
-            <a:off x="868680" y="5212080"/>
+            <a:off x="868680" y="5303519"/>
             <a:ext cx="1234440" cy="365760"/>
           </a:xfrm>
           <a:prstGeom prst="rect">
@@ -31150,7 +31150,7 @@
         </p:nvSpPr>
         <p:spPr>
           <a:xfrm>
-            <a:off x="2194560" y="4983480"/>
+            <a:off x="2194560" y="5074919"/>
             <a:ext cx="2926080" cy="822960"/>
           </a:xfrm>
           <a:prstGeom prst="roundRect">
@@ -31197,7 +31197,7 @@
         </p:nvSpPr>
         <p:spPr>
           <a:xfrm>
-            <a:off x="2194560" y="4983480"/>
+            <a:off x="2194560" y="5074919"/>
             <a:ext cx="50800" cy="822960"/>
           </a:xfrm>
           <a:prstGeom prst="rect">
@@ -31240,7 +31240,7 @@
         </p:nvSpPr>
         <p:spPr>
           <a:xfrm>
-            <a:off x="2377440" y="5056632"/>
+            <a:off x="2377440" y="5148071"/>
             <a:ext cx="2286000" cy="182880"/>
           </a:xfrm>
           <a:prstGeom prst="rect">
@@ -31276,7 +31276,7 @@
         </p:nvSpPr>
         <p:spPr>
           <a:xfrm>
-            <a:off x="2377440" y="5212080"/>
+            <a:off x="2377440" y="5303519"/>
             <a:ext cx="2560320" cy="274320"/>
           </a:xfrm>
           <a:prstGeom prst="rect">
@@ -31312,7 +31312,7 @@
         </p:nvSpPr>
         <p:spPr>
           <a:xfrm>
-            <a:off x="2377440" y="5486400"/>
+            <a:off x="2377440" y="5577839"/>
             <a:ext cx="2560320" cy="274320"/>
           </a:xfrm>
           <a:prstGeom prst="rect">
@@ -31348,7 +31348,7 @@
         </p:nvSpPr>
         <p:spPr>
           <a:xfrm>
-            <a:off x="5257800" y="4983480"/>
+            <a:off x="5257800" y="5074919"/>
             <a:ext cx="2926080" cy="822960"/>
           </a:xfrm>
           <a:prstGeom prst="roundRect">
@@ -31395,7 +31395,7 @@
         </p:nvSpPr>
         <p:spPr>
           <a:xfrm>
-            <a:off x="5440680" y="5212080"/>
+            <a:off x="5440680" y="5303519"/>
             <a:ext cx="2560320" cy="274320"/>
           </a:xfrm>
           <a:prstGeom prst="rect">
@@ -31431,7 +31431,7 @@
         </p:nvSpPr>
         <p:spPr>
           <a:xfrm>
-            <a:off x="5440680" y="5486400"/>
+            <a:off x="5440680" y="5577839"/>
             <a:ext cx="2560320" cy="274320"/>
           </a:xfrm>
           <a:prstGeom prst="rect">
@@ -31467,7 +31467,7 @@
         </p:nvSpPr>
         <p:spPr>
           <a:xfrm>
-            <a:off x="8321040" y="4983480"/>
+            <a:off x="8321040" y="5074919"/>
             <a:ext cx="2926080" cy="822960"/>
           </a:xfrm>
           <a:prstGeom prst="roundRect">
@@ -31514,7 +31514,7 @@
         </p:nvSpPr>
         <p:spPr>
           <a:xfrm>
-            <a:off x="8503920" y="5212080"/>
+            <a:off x="8503920" y="5303519"/>
             <a:ext cx="2560320" cy="274320"/>
           </a:xfrm>
           <a:prstGeom prst="rect">
@@ -31550,7 +31550,7 @@
         </p:nvSpPr>
         <p:spPr>
           <a:xfrm>
-            <a:off x="8503920" y="5486400"/>
+            <a:off x="8503920" y="5577839"/>
             <a:ext cx="2560320" cy="274320"/>
           </a:xfrm>
           <a:prstGeom prst="rect">
@@ -31586,7 +31586,7 @@
         </p:nvSpPr>
         <p:spPr>
           <a:xfrm>
-            <a:off x="594360" y="4910328"/>
+            <a:off x="594360" y="5001767"/>
             <a:ext cx="10927080" cy="969264"/>
           </a:xfrm>
           <a:prstGeom prst="rect">
@@ -31629,7 +31629,7 @@
         </p:nvSpPr>
         <p:spPr>
           <a:xfrm>
-            <a:off x="9784080" y="4690872"/>
+            <a:off x="9784080" y="4782311"/>
             <a:ext cx="1645920" cy="201168"/>
           </a:xfrm>
           <a:prstGeom prst="rect">

</xml_diff>

<commit_message>
Align intro slide cards with ecosystem slide brand order
Restructure intro cards to match the ecosystem flow on slide 3.
Combine drivetrains and brakes into one SRAM card. Add Hammerhead
and TIME. Remove AXS (platform, not a brand).
</commit_message>
<xml_diff>
--- a/deliverables/SRAM_AI_Adoption_Playbook.pptx
+++ b/deliverables/SRAM_AI_Adoption_Playbook.pptx
@@ -14899,7 +14899,7 @@
               </a:defRPr>
             </a:pPr>
             <a:r>
-              <a:t>Drivetrains</a:t>
+              <a:t>Drivetrains + Braking</a:t>
             </a:r>
           </a:p>
         </p:txBody>
@@ -14935,11 +14935,11 @@
               </a:defRPr>
             </a:pPr>
             <a:r>
-              <a:t>Gears and chains that</a:t>
+              <a:t>Gears, chains, and disc</a:t>
             </a:r>
             <a:br/>
             <a:r>
-              <a:t>make bikes go fast</a:t>
+              <a:t>brakes for every bike</a:t>
             </a:r>
           </a:p>
         </p:txBody>
@@ -15022,7 +15022,7 @@
               </a:defRPr>
             </a:pPr>
             <a:r>
-              <a:t>SRAM</a:t>
+              <a:t>RockShox</a:t>
             </a:r>
           </a:p>
         </p:txBody>
@@ -15058,7 +15058,7 @@
               </a:defRPr>
             </a:pPr>
             <a:r>
-              <a:t>Brakes</a:t>
+              <a:t>Suspension</a:t>
             </a:r>
           </a:p>
         </p:txBody>
@@ -15094,11 +15094,11 @@
               </a:defRPr>
             </a:pPr>
             <a:r>
-              <a:t>Disc brakes that help</a:t>
+              <a:t>Forks that absorb</a:t>
             </a:r>
             <a:br/>
             <a:r>
-              <a:t>riders stop safely</a:t>
+              <a:t>bumps on trails</a:t>
             </a:r>
           </a:p>
         </p:txBody>
@@ -15181,7 +15181,7 @@
               </a:defRPr>
             </a:pPr>
             <a:r>
-              <a:t>RockShox</a:t>
+              <a:t>Zipp</a:t>
             </a:r>
           </a:p>
         </p:txBody>
@@ -15217,7 +15217,7 @@
               </a:defRPr>
             </a:pPr>
             <a:r>
-              <a:t>Suspension</a:t>
+              <a:t>Wheels + Cockpit</a:t>
             </a:r>
           </a:p>
         </p:txBody>
@@ -15253,11 +15253,11 @@
               </a:defRPr>
             </a:pPr>
             <a:r>
-              <a:t>Forks that absorb</a:t>
+              <a:t>Aero wheels built</a:t>
             </a:r>
             <a:br/>
             <a:r>
-              <a:t>bumps on trails</a:t>
+              <a:t>for speed</a:t>
             </a:r>
           </a:p>
         </p:txBody>
@@ -15340,7 +15340,7 @@
               </a:defRPr>
             </a:pPr>
             <a:r>
-              <a:t>Zipp</a:t>
+              <a:t>Quarq</a:t>
             </a:r>
           </a:p>
         </p:txBody>
@@ -15376,7 +15376,7 @@
               </a:defRPr>
             </a:pPr>
             <a:r>
-              <a:t>Wheels</a:t>
+              <a:t>Power Meters</a:t>
             </a:r>
           </a:p>
         </p:txBody>
@@ -15412,11 +15412,11 @@
               </a:defRPr>
             </a:pPr>
             <a:r>
-              <a:t>Aero wheels built</a:t>
+              <a:t>Sensors that measure</a:t>
             </a:r>
             <a:br/>
             <a:r>
-              <a:t>for speed</a:t>
+              <a:t>rider performance</a:t>
             </a:r>
           </a:p>
         </p:txBody>
@@ -15499,7 +15499,7 @@
               </a:defRPr>
             </a:pPr>
             <a:r>
-              <a:t>Quarq</a:t>
+              <a:t>Hammerhead</a:t>
             </a:r>
           </a:p>
         </p:txBody>
@@ -15535,7 +15535,7 @@
               </a:defRPr>
             </a:pPr>
             <a:r>
-              <a:t>Sensors</a:t>
+              <a:t>Cycling Computer</a:t>
             </a:r>
           </a:p>
         </p:txBody>
@@ -15571,11 +15571,11 @@
               </a:defRPr>
             </a:pPr>
             <a:r>
-              <a:t>Power meters that</a:t>
+              <a:t>GPS device for navigation,</a:t>
             </a:r>
             <a:br/>
             <a:r>
-              <a:t>measure performance</a:t>
+              <a:t>training, and data</a:t>
             </a:r>
           </a:p>
         </p:txBody>
@@ -15658,7 +15658,7 @@
               </a:defRPr>
             </a:pPr>
             <a:r>
-              <a:t>AXS</a:t>
+              <a:t>TIME</a:t>
             </a:r>
           </a:p>
         </p:txBody>
@@ -15694,7 +15694,7 @@
               </a:defRPr>
             </a:pPr>
             <a:r>
-              <a:t>App</a:t>
+              <a:t>Pedals</a:t>
             </a:r>
           </a:p>
         </p:txBody>
@@ -15730,11 +15730,11 @@
               </a:defRPr>
             </a:pPr>
             <a:r>
-              <a:t>Connects all components</a:t>
+              <a:t>Clipless pedal systems</a:t>
             </a:r>
             <a:br/>
             <a:r>
-              <a:t>into one digital ecosystem</a:t>
+              <a:t>for road and mountain</a:t>
             </a:r>
           </a:p>
         </p:txBody>

</xml_diff>

<commit_message>
Add team member names to title slide
</commit_message>
<xml_diff>
--- a/deliverables/SRAM_AI_Adoption_Playbook.pptx
+++ b/deliverables/SRAM_AI_Adoption_Playbook.pptx
@@ -3274,6 +3274,35 @@
             </a:pPr>
             <a:r>
               <a:t>Prepared for Executive Leadership  |  March 2026</a:t>
+            </a:r>
+          </a:p>
+          <a:p>
+            <a:pPr>
+              <a:spcAft>
+                <a:spcPts val="360"/>
+              </a:spcAft>
+              <a:defRPr sz="600" b="0">
+                <a:solidFill>
+                  <a:srgbClr val="767676"/>
+                </a:solidFill>
+                <a:latin typeface="Calibri"/>
+              </a:defRPr>
+            </a:pPr>
+          </a:p>
+          <a:p>
+            <a:pPr>
+              <a:spcAft>
+                <a:spcPts val="780"/>
+              </a:spcAft>
+              <a:defRPr sz="1300" b="0">
+                <a:solidFill>
+                  <a:srgbClr val="767676"/>
+                </a:solidFill>
+                <a:latin typeface="Calibri"/>
+              </a:defRPr>
+            </a:pPr>
+            <a:r>
+              <a:t>Donovan Palmer, Ed Kreienberg, Will Zheng</a:t>
             </a:r>
           </a:p>
         </p:txBody>

</xml_diff>